<commit_message>
Add access slide, UI demos (trolley, creative, Score) and repo links
- Deck (6 slides): crop the clickbait banner on slide 3, new 'Getting access' slide (Jev not public, not in the Microsoft Foundry catalog; TypeSafe sign-up, Foundry OpenAPI-tool pattern from the Tech Community article, open-source Laya, how to run), repo links, live-demo slide with three UI screenshots
- samples/07_ui_demos.py + samples/ui: stdlib web server with three browser demos - trolley problem x100 (Choice), creative emoji pile (Noul, streamed, relative threshold, cached warm-up) and 'How hot is this message?' (4 Score gauges, priority + route in code)
- READMEs: getting access, clone/run instructions, UI demo docs, new lessons learned

Co-authored-by: Copilot App <223556219+Copilot@users.noreply.github.com>
</commit_message>
<xml_diff>
--- a/presentation/Jev_Team_Overview.pptx
+++ b/presentation/Jev_Team_Overview.pptx
@@ -9,6 +9,8 @@
     <p:sldId id="257" r:id="rId9"/>
     <p:sldId id="258" r:id="rId10"/>
     <p:sldId id="259" r:id="rId11"/>
+    <p:sldId id="260" r:id="rId12"/>
+    <p:sldId id="261" r:id="rId13"/>
   </p:sldIdLst>
   <p:sldSz cx="12191695" cy="6858000" type="screen4x3"/>
   <p:notesSz cx="6858000" cy="9144000"/>
@@ -851,12 +853,135 @@
           <a:lstStyle/>
           <a:p>
             <a:r>
-              <a:t>REPO: samples/ - six runnable Python samples + jev_client.py (local Laya backend or any Jev-compatible HTTP endpoint via JEV_BASE_URL / JEV_API_KEY). Run: python -m venv .venv; .venv\Scripts\pip install -r samples\requirements.txt; cd samples; ..\.venv\Scripts\python 01_lead_scoring.py</a:t>
+              <a:t>AVAILABILITY: Jev (TypeSafe AI) has been in early access since 15 Sep 2026. You apply for the preview, then create an API key under "API keys" (free starter credit is typical). It is NOT in the Microsoft Foundry model catalog - there is no one-click deployment.</a:t>
             </a:r>
           </a:p>
           <a:p/>
           <a:p>
             <a:r>
+              <a:t>MICROSOFT FOUNDRY (Microsoft Tech Community, "Using Jev with Agents in Microsoft Foundry for Model Evaluation", 30 Sep 2026):</a:t>
+            </a:r>
+          </a:p>
+          <a:p>
+            <a:r>
+              <a:t>- Create a Foundry agent, add an OpenAPI tool with an OpenAPI 3.0 schema for POST https://api.typesafe.ai/v1/systemone (operationId evaluate_with_jev; Noul / Choice / Score question schemas) and a new connection holding the key as "Bearer &lt;key&gt;".</a:t>
+            </a:r>
+          </a:p>
+          <a:p>
+            <a:r>
+              <a:t>- Agent instructions: for every support message MUST call evaluate_with_jev, use exactly 'instructions' and 'criteria' properties, model "jev-latest", pass the original message as state, do not classify yourself, show the Jev output.</a:t>
+            </a:r>
+          </a:p>
+          <a:p>
+            <a:r>
+              <a:t>- Example from the article: "The room had no water in and one of the towels was dirty" -&gt; billing noul 0.02, tone choice frustrated (0.74, confidence 0.6), urgency score 1.81 (handle today 0.85). The application then routes / escalates / requires human review deterministically.</a:t>
+            </a:r>
+          </a:p>
+          <a:p>
+            <a:r>
+              <a:t>- Pattern: User/Application -&gt; Foundry model or agent -&gt; Jev judgement -&gt; deterministic logic -&gt; action/response.</a:t>
+            </a:r>
+          </a:p>
+          <a:p>
+            <a:r>
+              <a:t>- Why Jev: consistent evaluation against explicit criteria, structured outputs, classification/routing, guardrails before tool calls, model routing; every decision has a probability for thresholds.</a:t>
+            </a:r>
+          </a:p>
+          <a:p>
+            <a:r>
+              <a:t>- Explainability: SHAP-style attribution is hard when the model is only reachable through a hosted API. Jev does not replace SHAP but adds a separate, measurable judgement layer around opaque MaaS models.</a:t>
+            </a:r>
+          </a:p>
+          <a:p>
+            <a:r>
+              <a:t>- Pricing (Sept 2026): jev-1.13.0 $0.042 per 1M input tokens, output free; limits 250,000 tokens/s and 1,200 requests/min (subject to change). Typical latency ~70-500 ms.</a:t>
+            </a:r>
+          </a:p>
+          <a:p/>
+          <a:p>
+            <a:r>
+              <a:t>OPEN SOURCE: Laya (huggingface.co/convaiinnovations/laya) - Apache-2.0, Jev-compatible request/response shape, runs locally; laya-serve exposes POST /v1/systemone so Jev clients only change the base URL. All our samples run on it.</a:t>
+            </a:r>
+          </a:p>
+          <a:p/>
+          <a:p>
+            <a:r>
+              <a:t>RUN THE SAMPLES: git clone https://github.com/stvonolf/jev-samples; python -m venv .venv; .venv\Scripts\python -m pip install -r samples\requirements.txt; cd samples; ..\.venv\Scripts\python 01_lead_scoring.py (01-06), ..\.venv\Scripts\python 07_ui_demos.py for the browser demos (http://localhost:8765). First run downloads ~0.8 GB of model weights.</a:t>
+            </a:r>
+          </a:p>
+        </p:txBody>
+      </p:sp>
+      <p:sp>
+        <p:nvSpPr>
+          <p:cNvPr id="4" name="Slide Number Placeholder 3"/>
+          <p:cNvSpPr>
+            <a:spLocks noGrp="1"/>
+          </p:cNvSpPr>
+          <p:nvPr>
+            <p:ph type="sldNum" idx="5" sz="quarter"/>
+          </p:nvPr>
+        </p:nvSpPr>
+        <p:spPr/>
+      </p:sp>
+    </p:spTree>
+  </p:cSld>
+  <p:clrMapOvr>
+    <a:masterClrMapping/>
+  </p:clrMapOvr>
+</p:notes>
+</file>
+
+<file path=ppt/notesSlides/notesSlide5.xml><?xml version="1.0" encoding="utf-8"?>
+<p:notes xmlns:a="http://schemas.openxmlformats.org/drawingml/2006/main" xmlns:p="http://schemas.openxmlformats.org/presentationml/2006/main" xmlns:r="http://schemas.openxmlformats.org/officeDocument/2006/relationships">
+  <p:cSld>
+    <p:spTree>
+      <p:nvGrpSpPr>
+        <p:cNvPr id="1" name=""/>
+        <p:cNvGrpSpPr/>
+        <p:nvPr/>
+      </p:nvGrpSpPr>
+      <p:grpSpPr>
+        <a:xfrm>
+          <a:off x="0" y="0"/>
+          <a:ext cx="0" cy="0"/>
+          <a:chOff x="0" y="0"/>
+          <a:chExt cx="0" cy="0"/>
+        </a:xfrm>
+      </p:grpSpPr>
+      <p:sp>
+        <p:nvSpPr>
+          <p:cNvPr id="2" name="Slide Image Placeholder 1"/>
+          <p:cNvSpPr>
+            <a:spLocks noGrp="1"/>
+          </p:cNvSpPr>
+          <p:nvPr>
+            <p:ph type="sldImg" idx="2"/>
+          </p:nvPr>
+        </p:nvSpPr>
+        <p:spPr/>
+      </p:sp>
+      <p:sp>
+        <p:nvSpPr>
+          <p:cNvPr id="3" name="Notes Placeholder 2"/>
+          <p:cNvSpPr>
+            <a:spLocks noGrp="1"/>
+          </p:cNvSpPr>
+          <p:nvPr>
+            <p:ph type="body" idx="3" sz="quarter"/>
+          </p:nvPr>
+        </p:nvSpPr>
+        <p:spPr/>
+        <p:txBody>
+          <a:bodyPr/>
+          <a:lstStyle/>
+          <a:p>
+            <a:r>
+              <a:t>REPO: https://github.com/stvonolf/jev-samples - samples/ has seven runnable Python samples + jev_client.py (local Laya backend or any Jev-compatible HTTP endpoint via JEV_BASE_URL / JEV_API_KEY). Run: git clone https://github.com/stvonolf/jev-samples; cd jev-samples; python -m venv .venv; .venv\Scripts\python -m pip install -r samples\requirements.txt; cd samples; ..\.venv\Scripts\python 01_lead_scoring.py (01-06 are console samples); ..\.venv\Scripts\python 07_ui_demos.py starts the browser demos on http://localhost:8765.</a:t>
+            </a:r>
+          </a:p>
+          <a:p/>
+          <a:p>
+            <a:r>
               <a:t>LAYA (huggingface.co/convaiinnovations/laya): ModernBERT-large backbone (395M) + a decision head trained from scratch, 421M total; multilingual checkpoint on mmBERT-base for 100+ languages; trained with RLCD-style proper scoring rules. laya-serve exposes the same POST /v1/systemone request/response shape as TypeSafe Jev. Author-reported vs Jev (third-party numbers, different setups): 7.8x faster on a T4 GPU (32.8 ms vs 236-276 ms p50), better calibration after temperature fitting, but Jev is better with &gt;20 options (Banking77: 0.87 vs 0.43). The base checkpoint scores 0.36 on the typed-decisions benchmark; the fine-tuned typed-decisions checkpoint 0.77 - fine-tuning matters.</a:t>
             </a:r>
           </a:p>
@@ -876,6 +1001,100 @@
           <a:p>
             <a:r>
               <a:t>NEXT STEPS: one pilot use case, label data, measure Laya vs Jev, ship behind confidence gating with human review for the middle band.</a:t>
+            </a:r>
+          </a:p>
+        </p:txBody>
+      </p:sp>
+      <p:sp>
+        <p:nvSpPr>
+          <p:cNvPr id="4" name="Slide Number Placeholder 3"/>
+          <p:cNvSpPr>
+            <a:spLocks noGrp="1"/>
+          </p:cNvSpPr>
+          <p:nvPr>
+            <p:ph type="sldNum" idx="5" sz="quarter"/>
+          </p:nvPr>
+        </p:nvSpPr>
+        <p:spPr/>
+      </p:sp>
+    </p:spTree>
+  </p:cSld>
+  <p:clrMapOvr>
+    <a:masterClrMapping/>
+  </p:clrMapOvr>
+</p:notes>
+</file>
+
+<file path=ppt/notesSlides/notesSlide6.xml><?xml version="1.0" encoding="utf-8"?>
+<p:notes xmlns:a="http://schemas.openxmlformats.org/drawingml/2006/main" xmlns:p="http://schemas.openxmlformats.org/presentationml/2006/main" xmlns:r="http://schemas.openxmlformats.org/officeDocument/2006/relationships">
+  <p:cSld>
+    <p:spTree>
+      <p:nvGrpSpPr>
+        <p:cNvPr id="1" name=""/>
+        <p:cNvGrpSpPr/>
+        <p:nvPr/>
+      </p:nvGrpSpPr>
+      <p:grpSpPr>
+        <a:xfrm>
+          <a:off x="0" y="0"/>
+          <a:ext cx="0" cy="0"/>
+          <a:chOff x="0" y="0"/>
+          <a:chExt cx="0" cy="0"/>
+        </a:xfrm>
+      </p:grpSpPr>
+      <p:sp>
+        <p:nvSpPr>
+          <p:cNvPr id="2" name="Slide Image Placeholder 1"/>
+          <p:cNvSpPr>
+            <a:spLocks noGrp="1"/>
+          </p:cNvSpPr>
+          <p:nvPr>
+            <p:ph type="sldImg" idx="2"/>
+          </p:nvPr>
+        </p:nvSpPr>
+        <p:spPr/>
+      </p:sp>
+      <p:sp>
+        <p:nvSpPr>
+          <p:cNvPr id="3" name="Notes Placeholder 2"/>
+          <p:cNvSpPr>
+            <a:spLocks noGrp="1"/>
+          </p:cNvSpPr>
+          <p:nvPr>
+            <p:ph type="body" idx="3" sz="quarter"/>
+          </p:nvPr>
+        </p:nvSpPr>
+        <p:spPr/>
+        <p:txBody>
+          <a:bodyPr/>
+          <a:lstStyle/>
+          <a:p>
+            <a:r>
+              <a:t>SAMPLE 07 (samples/07_ui_demos.py): a stdlib-only web server on top of jev_client.DecisionClient - so it runs on local Laya by default and on TypeSafe Jev when JEV_BASE_URL / JEV_API_KEY are set. Open http://localhost:8765. One demo per primitive.</a:t>
+            </a:r>
+          </a:p>
+          <a:p/>
+          <a:p>
+            <a:r>
+              <a:t>TROLLEY (/trolley, Choice), modelled on the "The trolley problem, 100 times" demo from video 2 (X post by @FinanceYF5): one Choice per trial ("pull_the_lever" vs "leave_it_alone", criteria spell out who dies). Each trial uses freshly randomised wording (vehicle, people, sentence template), so the 100 decisions are not identical calls. First 5 trials at 1x, then 10x, like the original. Classic mode reproduces the video (100/100 pull). Sanity-check mode swaps the counts (1 on main, 5 on side) - Laya still pulls the lever (0 of 13 trials chose fewer deaths in our run), and a random-counts mode shows the same. Lesson: fast decision models pattern-match; put arithmetic and hard rules in code.</a:t>
+            </a:r>
+          </a:p>
+          <a:p/>
+          <a:p>
+            <a:r>
+              <a:t>CREATIVE (/creative, Noul), modelled on the designer demo (@heystefan_): type a request, every emoji in a pile of ~235 gets a Noul. Emoji that stand out for the request animate up under the prompt as decisions stream in, 8 per request. Because P(related) levels vary by prompt (wear ~0.9 max, lose weight ~0.3 max), the UI selects relative outliers (mean + 2.5 sd, at most 12). Speed on our laptop CPU: ~0.15-0.3 s per emoji decision, so a brand-new prompt takes ~40-75 s; the suggested prompts are pre-computed and cached at server start so they replay instantly. On a GPU or the Jev API this is real time.</a:t>
+            </a:r>
+          </a:p>
+          <a:p/>
+          <a:p>
+            <a:r>
+              <a:t>SCORE (/score): "How hot is this message?" - four Score questions about one customer message (frustration: calm/slightly annoyed/frustrated/furious; urgency: no time pressure ... emergency; churn risk: very unlikely ... about to cancel; sentiment: negative/neutral/positive), re-evaluated 0.7 s after you stop typing (~1.3-1.5 s per evaluation on the laptop CPU). Each gauge shades the levels by probability and puts a needle at the probability-weighted score, so you can see it land between levels. "Play escalation" types an invoice complaint sentence by sentence: frustration 0.96 -&gt; 1.42 -&gt; 1.84 -&gt; 2.11 -&gt; 2.44, churn jumps to 2.84 at "we will cancel". Priority = 0.40 frustration + 0.35 urgency + 0.25 churn (normalised) is computed in code and mapped to a route (normal queue / reply today / priority / escalate to retention; happy customers -&gt; testimonial for marketing). We first tried scoring short email subject lines - only urgency separated well, so Score works best on richer text.</a:t>
+            </a:r>
+          </a:p>
+          <a:p/>
+          <a:p>
+            <a:r>
+              <a:t>WHAT WE TRIED (creative): grouped Choice (10 emoji + "none" per question) was faster but less precise; mean-pooled encoder embeddings as a shortlist were no better than random; the emoji + name state with "Is this related to: X?" had the best ranking (AUC ~0.9 on labelled sets, except physics questions like magnets).</a:t>
             </a:r>
           </a:p>
         </p:txBody>
@@ -3926,7 +4145,7 @@
                 </a:solidFill>
                 <a:latin typeface="Segoe UI Semibold"/>
               </a:rPr>
-              <a:t>JEV · TEAM BRIEFING  ·  1 / 4</a:t>
+              <a:t>JEV · TEAM BRIEFING  ·  1 / 6</a:t>
             </a:r>
           </a:p>
         </p:txBody>
@@ -5173,6 +5392,59 @@
                 <a:latin typeface="Segoe UI"/>
               </a:rPr>
               <a:t>Demo from “Building a Harness with Jev” – LangChain</a:t>
+            </a:r>
+          </a:p>
+        </p:txBody>
+      </p:sp>
+      <p:sp>
+        <p:nvSpPr>
+          <p:cNvPr id="25" name="TextBox 24">
+            <a:hlinkClick r:id="rId5"/>
+          </p:cNvPr>
+          <p:cNvSpPr txBox="1"/>
+          <p:nvPr/>
+        </p:nvSpPr>
+        <p:spPr>
+          <a:xfrm>
+            <a:off x="457200" y="6309360"/>
+            <a:ext cx="6675120" cy="292608"/>
+          </a:xfrm>
+          <a:prstGeom prst="rect">
+            <a:avLst/>
+          </a:prstGeom>
+          <a:noFill/>
+        </p:spPr>
+        <p:txBody>
+          <a:bodyPr wrap="square" anchor="t" lIns="36576" rIns="36576" tIns="36576" bIns="36576">
+            <a:spAutoFit/>
+          </a:bodyPr>
+          <a:lstStyle/>
+          <a:p>
+            <a:pPr algn="l">
+              <a:lnSpc>
+                <a:spcPct val="100000"/>
+              </a:lnSpc>
+              <a:spcAft>
+                <a:spcPts val="0"/>
+              </a:spcAft>
+            </a:pPr>
+            <a:r>
+              <a:rPr sz="1200" b="0" i="0">
+                <a:solidFill>
+                  <a:srgbClr val="A3A9BC"/>
+                </a:solidFill>
+                <a:latin typeface="Segoe UI"/>
+              </a:rPr>
+              <a:t>Slides, samples &amp; UI demos:  </a:t>
+            </a:r>
+            <a:r>
+              <a:rPr sz="1200" b="0" i="0" u="sng">
+                <a:solidFill>
+                  <a:srgbClr val="22D3EE"/>
+                </a:solidFill>
+                <a:latin typeface="Segoe UI Semibold"/>
+              </a:rPr>
+              <a:t>github.com/stvonolf/jev-samples</a:t>
             </a:r>
           </a:p>
         </p:txBody>
@@ -5240,7 +5512,7 @@
                 </a:solidFill>
                 <a:latin typeface="Segoe UI Semibold"/>
               </a:rPr>
-              <a:t>HOW IT WORKS  ·  2 / 4</a:t>
+              <a:t>HOW IT WORKS  ·  2 / 6</a:t>
             </a:r>
           </a:p>
         </p:txBody>
@@ -6790,7 +7062,7 @@
                 </a:solidFill>
                 <a:latin typeface="Segoe UI Semibold"/>
               </a:rPr>
-              <a:t>FOR MARKETING SOFTWARE  ·  3 / 4</a:t>
+              <a:t>FOR MARKETING SOFTWARE  ·  3 / 6</a:t>
             </a:r>
           </a:p>
         </p:txBody>
@@ -8126,7 +8398,7 @@
       </p:graphicFrame>
       <p:pic>
         <p:nvPicPr>
-          <p:cNvPr id="5" name="Picture 4" descr="yt_I34qxJjyms0.jpg">
+          <p:cNvPr id="5" name="Picture 4" descr="yt_I34qxJjyms0_demos.jpg">
             <a:hlinkClick r:id="rId3"/>
           </p:cNvPr>
           <p:cNvPicPr>
@@ -8143,7 +8415,7 @@
         <p:spPr>
           <a:xfrm>
             <a:off x="7772400" y="1280160"/>
-            <a:ext cx="3959352" cy="2227136"/>
+            <a:ext cx="3959352" cy="1781708"/>
           </a:xfrm>
           <a:prstGeom prst="rect">
             <a:avLst/>
@@ -8165,7 +8437,7 @@
         </p:nvSpPr>
         <p:spPr>
           <a:xfrm>
-            <a:off x="7772400" y="3529584"/>
+            <a:off x="7772400" y="3098444"/>
             <a:ext cx="3977639" cy="274320"/>
           </a:xfrm>
           <a:prstGeom prst="rect">
@@ -8207,8 +8479,8 @@
         </p:nvSpPr>
         <p:spPr>
           <a:xfrm>
-            <a:off x="7772400" y="3840480"/>
-            <a:ext cx="3977639" cy="1005840"/>
+            <a:off x="7772400" y="3445916"/>
+            <a:ext cx="3977639" cy="1463040"/>
           </a:xfrm>
           <a:prstGeom prst="rect">
             <a:avLst/>
@@ -8226,7 +8498,7 @@
                 <a:spcPct val="100000"/>
               </a:lnSpc>
               <a:spcAft>
-                <a:spcPts val="300"/>
+                <a:spcPts val="400"/>
               </a:spcAft>
             </a:pPr>
             <a:r>
@@ -8254,7 +8526,7 @@
                 <a:spcPct val="100000"/>
               </a:lnSpc>
               <a:spcAft>
-                <a:spcPts val="300"/>
+                <a:spcPts val="400"/>
               </a:spcAft>
             </a:pPr>
             <a:r>
@@ -8273,7 +8545,35 @@
                 </a:solidFill>
                 <a:latin typeface="Segoe UI"/>
               </a:rPr>
-              <a:t>driving sim, trolley problem 100/100, voice-controlled drawing app, live slop detector, Laya playing Snake at ~60 decisions/s</a:t>
+              <a:t>driving sim, trolley problem 100/100, designer's emoji explorer, voice-controlled drawing app, live slop detector, Laya playing Snake at ~60 decisions/s</a:t>
+            </a:r>
+          </a:p>
+          <a:p>
+            <a:pPr algn="l">
+              <a:lnSpc>
+                <a:spcPct val="100000"/>
+              </a:lnSpc>
+              <a:spcAft>
+                <a:spcPts val="400"/>
+              </a:spcAft>
+            </a:pPr>
+            <a:r>
+              <a:rPr sz="1050" b="0" i="0">
+                <a:solidFill>
+                  <a:srgbClr val="22D3EE"/>
+                </a:solidFill>
+                <a:latin typeface="Segoe UI Semibold"/>
+              </a:rPr>
+              <a:t>We rebuilt two of them </a:t>
+            </a:r>
+            <a:r>
+              <a:rPr sz="1050" b="0" i="0">
+                <a:solidFill>
+                  <a:srgbClr val="22D3EE"/>
+                </a:solidFill>
+                <a:latin typeface="Segoe UI"/>
+              </a:rPr>
+              <a:t>→ slide 6</a:t>
             </a:r>
           </a:p>
         </p:txBody>
@@ -8917,7 +9217,7 @@
                 </a:solidFill>
                 <a:latin typeface="Segoe UI Semibold"/>
               </a:rPr>
-              <a:t>HANDS-ON  ·  4 / 4</a:t>
+              <a:t>GETTING ACCESS  ·  4 / 6</a:t>
             </a:r>
           </a:p>
         </p:txBody>
@@ -8959,7 +9259,7 @@
                 </a:solidFill>
                 <a:latin typeface="Segoe UI Semibold"/>
               </a:rPr>
-              <a:t>We built it: 6 samples running locally on Laya</a:t>
+              <a:t>Jev is not publicly available yet - not even in Microsoft Foundry</a:t>
             </a:r>
           </a:p>
         </p:txBody>
@@ -9001,22 +9301,1852 @@
                 </a:solidFill>
                 <a:latin typeface="Segoe UI"/>
               </a:rPr>
-              <a:t>Laya: open-source (Apache-2.0), Jev-compatible, 421M params, same /v1/systemone shape. Runs on a laptop CPU.</a:t>
+              <a:t>Early access since 15 Sep 2026, sign-up required. Three ways to work with a System One model today:</a:t>
+            </a:r>
+          </a:p>
+        </p:txBody>
+      </p:sp>
+      <p:sp>
+        <p:nvSpPr>
+          <p:cNvPr id="5" name="Rounded Rectangle 4"/>
+          <p:cNvSpPr/>
+          <p:nvPr/>
+        </p:nvSpPr>
+        <p:spPr>
+          <a:xfrm>
+            <a:off x="457200" y="1600200"/>
+            <a:ext cx="3611880" cy="2834640"/>
+          </a:xfrm>
+          <a:prstGeom prst="roundRect">
+            <a:avLst>
+              <a:gd name="adj" fmla="val 6000"/>
+            </a:avLst>
+          </a:prstGeom>
+          <a:solidFill>
+            <a:srgbClr val="1A1D27"/>
+          </a:solidFill>
+          <a:ln>
+            <a:noFill/>
+          </a:ln>
+          <a:effectLst/>
+        </p:spPr>
+        <p:style>
+          <a:lnRef idx="1">
+            <a:schemeClr val="accent1"/>
+          </a:lnRef>
+          <a:fillRef idx="3">
+            <a:schemeClr val="accent1"/>
+          </a:fillRef>
+          <a:effectRef idx="2">
+            <a:schemeClr val="accent1"/>
+          </a:effectRef>
+          <a:fontRef idx="minor">
+            <a:schemeClr val="lt1"/>
+          </a:fontRef>
+        </p:style>
+        <p:txBody>
+          <a:bodyPr rtlCol="0" anchor="ctr"/>
+          <a:lstStyle/>
+          <a:p/>
+        </p:txBody>
+      </p:sp>
+      <p:sp>
+        <p:nvSpPr>
+          <p:cNvPr id="6" name="Rectangle 5"/>
+          <p:cNvSpPr/>
+          <p:nvPr/>
+        </p:nvSpPr>
+        <p:spPr>
+          <a:xfrm>
+            <a:off x="457200" y="1600200"/>
+            <a:ext cx="3611880" cy="64008"/>
+          </a:xfrm>
+          <a:prstGeom prst="rect">
+            <a:avLst/>
+          </a:prstGeom>
+          <a:solidFill>
+            <a:srgbClr val="FBBF24"/>
+          </a:solidFill>
+          <a:ln>
+            <a:noFill/>
+          </a:ln>
+          <a:effectLst/>
+        </p:spPr>
+        <p:style>
+          <a:lnRef idx="1">
+            <a:schemeClr val="accent1"/>
+          </a:lnRef>
+          <a:fillRef idx="3">
+            <a:schemeClr val="accent1"/>
+          </a:fillRef>
+          <a:effectRef idx="2">
+            <a:schemeClr val="accent1"/>
+          </a:effectRef>
+          <a:fontRef idx="minor">
+            <a:schemeClr val="lt1"/>
+          </a:fontRef>
+        </p:style>
+        <p:txBody>
+          <a:bodyPr rtlCol="0" anchor="ctr"/>
+          <a:lstStyle/>
+          <a:p/>
+        </p:txBody>
+      </p:sp>
+      <p:sp>
+        <p:nvSpPr>
+          <p:cNvPr id="7" name="TextBox 6"/>
+          <p:cNvSpPr txBox="1"/>
+          <p:nvPr/>
+        </p:nvSpPr>
+        <p:spPr>
+          <a:xfrm>
+            <a:off x="621792" y="1746504"/>
+            <a:ext cx="3337560" cy="365760"/>
+          </a:xfrm>
+          <a:prstGeom prst="rect">
+            <a:avLst/>
+          </a:prstGeom>
+          <a:noFill/>
+        </p:spPr>
+        <p:txBody>
+          <a:bodyPr wrap="square" anchor="t" lIns="36576" rIns="36576" tIns="36576" bIns="36576">
+            <a:spAutoFit/>
+          </a:bodyPr>
+          <a:lstStyle/>
+          <a:p>
+            <a:pPr algn="l">
+              <a:lnSpc>
+                <a:spcPct val="100000"/>
+              </a:lnSpc>
+              <a:spcAft>
+                <a:spcPts val="0"/>
+              </a:spcAft>
+            </a:pPr>
+            <a:r>
+              <a:rPr sz="1450" b="0" i="0">
+                <a:solidFill>
+                  <a:srgbClr val="FBBF24"/>
+                </a:solidFill>
+                <a:latin typeface="Segoe UI Semibold"/>
+              </a:rPr>
+              <a:t>①  TypeSafe API  (sign-up)</a:t>
+            </a:r>
+          </a:p>
+        </p:txBody>
+      </p:sp>
+      <p:sp>
+        <p:nvSpPr>
+          <p:cNvPr id="8" name="TextBox 7"/>
+          <p:cNvSpPr txBox="1"/>
+          <p:nvPr/>
+        </p:nvSpPr>
+        <p:spPr>
+          <a:xfrm>
+            <a:off x="621792" y="2148840"/>
+            <a:ext cx="3337560" cy="1920240"/>
+          </a:xfrm>
+          <a:prstGeom prst="rect">
+            <a:avLst/>
+          </a:prstGeom>
+          <a:noFill/>
+        </p:spPr>
+        <p:txBody>
+          <a:bodyPr wrap="square" anchor="t" lIns="36576" rIns="36576" tIns="36576" bIns="36576">
+            <a:spAutoFit/>
+          </a:bodyPr>
+          <a:lstStyle/>
+          <a:p>
+            <a:pPr algn="l">
+              <a:lnSpc>
+                <a:spcPct val="100000"/>
+              </a:lnSpc>
+              <a:spcAft>
+                <a:spcPts val="500"/>
+              </a:spcAft>
+            </a:pPr>
+            <a:r>
+              <a:rPr sz="1050" b="0" i="0">
+                <a:solidFill>
+                  <a:srgbClr val="FBBF24"/>
+                </a:solidFill>
+                <a:latin typeface="Segoe UI"/>
+              </a:rPr>
+              <a:t>•  </a:t>
+            </a:r>
+            <a:r>
+              <a:rPr sz="1050" b="0" i="0">
+                <a:solidFill>
+                  <a:srgbClr val="F5F6FA"/>
+                </a:solidFill>
+                <a:latin typeface="Segoe UI"/>
+              </a:rPr>
+              <a:t>Apply for the preview at typesafe.ai, then create an API key (comes with free credit).</a:t>
+            </a:r>
+          </a:p>
+          <a:p>
+            <a:pPr algn="l">
+              <a:lnSpc>
+                <a:spcPct val="100000"/>
+              </a:lnSpc>
+              <a:spcAft>
+                <a:spcPts val="500"/>
+              </a:spcAft>
+            </a:pPr>
+            <a:r>
+              <a:rPr sz="1050" b="0" i="0">
+                <a:solidFill>
+                  <a:srgbClr val="FBBF24"/>
+                </a:solidFill>
+                <a:latin typeface="Segoe UI"/>
+              </a:rPr>
+              <a:t>•  </a:t>
+            </a:r>
+            <a:r>
+              <a:rPr sz="1050" b="0" i="0">
+                <a:solidFill>
+                  <a:srgbClr val="F5F6FA"/>
+                </a:solidFill>
+                <a:latin typeface="Segoe UI"/>
+              </a:rPr>
+              <a:t>POST api.typesafe.ai/v1/systemone, model “jev-latest”; SDKs and langchain-typesafe.</a:t>
+            </a:r>
+          </a:p>
+          <a:p>
+            <a:pPr algn="l">
+              <a:lnSpc>
+                <a:spcPct val="100000"/>
+              </a:lnSpc>
+              <a:spcAft>
+                <a:spcPts val="500"/>
+              </a:spcAft>
+            </a:pPr>
+            <a:r>
+              <a:rPr sz="1050" b="0" i="0">
+                <a:solidFill>
+                  <a:srgbClr val="FBBF24"/>
+                </a:solidFill>
+                <a:latin typeface="Segoe UI"/>
+              </a:rPr>
+              <a:t>•  </a:t>
+            </a:r>
+            <a:r>
+              <a:rPr sz="1050" b="0" i="0">
+                <a:solidFill>
+                  <a:srgbClr val="F5F6FA"/>
+                </a:solidFill>
+                <a:latin typeface="Segoe UI"/>
+              </a:rPr>
+              <a:t>$0.042 per 1M input tokens, output free · 250k tokens/s, 1,200 requests/min.</a:t>
+            </a:r>
+          </a:p>
+          <a:p>
+            <a:pPr algn="l">
+              <a:lnSpc>
+                <a:spcPct val="100000"/>
+              </a:lnSpc>
+              <a:spcAft>
+                <a:spcPts val="500"/>
+              </a:spcAft>
+            </a:pPr>
+            <a:r>
+              <a:rPr sz="1050" b="0" i="0">
+                <a:solidFill>
+                  <a:srgbClr val="FBBF24"/>
+                </a:solidFill>
+                <a:latin typeface="Segoe UI"/>
+              </a:rPr>
+              <a:t>•  </a:t>
+            </a:r>
+            <a:r>
+              <a:rPr sz="1050" b="0" i="0">
+                <a:solidFill>
+                  <a:srgbClr val="F5F6FA"/>
+                </a:solidFill>
+                <a:latin typeface="Segoe UI"/>
+              </a:rPr>
+              <a:t>Our samples: set JEV_BASE_URL + JEV_API_KEY.</a:t>
+            </a:r>
+          </a:p>
+        </p:txBody>
+      </p:sp>
+      <p:sp>
+        <p:nvSpPr>
+          <p:cNvPr id="9" name="TextBox 8">
+            <a:hlinkClick r:id="rId2"/>
+          </p:cNvPr>
+          <p:cNvSpPr txBox="1"/>
+          <p:nvPr/>
+        </p:nvSpPr>
+        <p:spPr>
+          <a:xfrm>
+            <a:off x="621792" y="4069079"/>
+            <a:ext cx="3337560" cy="292608"/>
+          </a:xfrm>
+          <a:prstGeom prst="rect">
+            <a:avLst/>
+          </a:prstGeom>
+          <a:noFill/>
+        </p:spPr>
+        <p:txBody>
+          <a:bodyPr wrap="square" anchor="t" lIns="36576" rIns="36576" tIns="36576" bIns="36576">
+            <a:spAutoFit/>
+          </a:bodyPr>
+          <a:lstStyle/>
+          <a:p>
+            <a:pPr algn="l">
+              <a:lnSpc>
+                <a:spcPct val="100000"/>
+              </a:lnSpc>
+              <a:spcAft>
+                <a:spcPts val="0"/>
+              </a:spcAft>
+            </a:pPr>
+            <a:r>
+              <a:rPr sz="1000" b="0" i="0" u="sng">
+                <a:solidFill>
+                  <a:srgbClr val="FBBF24"/>
+                </a:solidFill>
+                <a:latin typeface="Segoe UI Semibold"/>
+              </a:rPr>
+              <a:t>docs.typesafe.ai</a:t>
+            </a:r>
+          </a:p>
+        </p:txBody>
+      </p:sp>
+      <p:sp>
+        <p:nvSpPr>
+          <p:cNvPr id="10" name="Rounded Rectangle 9"/>
+          <p:cNvSpPr/>
+          <p:nvPr/>
+        </p:nvSpPr>
+        <p:spPr>
+          <a:xfrm>
+            <a:off x="4288536" y="1600200"/>
+            <a:ext cx="3611880" cy="2834640"/>
+          </a:xfrm>
+          <a:prstGeom prst="roundRect">
+            <a:avLst>
+              <a:gd name="adj" fmla="val 6000"/>
+            </a:avLst>
+          </a:prstGeom>
+          <a:solidFill>
+            <a:srgbClr val="1A1D27"/>
+          </a:solidFill>
+          <a:ln>
+            <a:noFill/>
+          </a:ln>
+          <a:effectLst/>
+        </p:spPr>
+        <p:style>
+          <a:lnRef idx="1">
+            <a:schemeClr val="accent1"/>
+          </a:lnRef>
+          <a:fillRef idx="3">
+            <a:schemeClr val="accent1"/>
+          </a:fillRef>
+          <a:effectRef idx="2">
+            <a:schemeClr val="accent1"/>
+          </a:effectRef>
+          <a:fontRef idx="minor">
+            <a:schemeClr val="lt1"/>
+          </a:fontRef>
+        </p:style>
+        <p:txBody>
+          <a:bodyPr rtlCol="0" anchor="ctr"/>
+          <a:lstStyle/>
+          <a:p/>
+        </p:txBody>
+      </p:sp>
+      <p:sp>
+        <p:nvSpPr>
+          <p:cNvPr id="11" name="Rectangle 10"/>
+          <p:cNvSpPr/>
+          <p:nvPr/>
+        </p:nvSpPr>
+        <p:spPr>
+          <a:xfrm>
+            <a:off x="4288536" y="1600200"/>
+            <a:ext cx="3611880" cy="64008"/>
+          </a:xfrm>
+          <a:prstGeom prst="rect">
+            <a:avLst/>
+          </a:prstGeom>
+          <a:solidFill>
+            <a:srgbClr val="22D3EE"/>
+          </a:solidFill>
+          <a:ln>
+            <a:noFill/>
+          </a:ln>
+          <a:effectLst/>
+        </p:spPr>
+        <p:style>
+          <a:lnRef idx="1">
+            <a:schemeClr val="accent1"/>
+          </a:lnRef>
+          <a:fillRef idx="3">
+            <a:schemeClr val="accent1"/>
+          </a:fillRef>
+          <a:effectRef idx="2">
+            <a:schemeClr val="accent1"/>
+          </a:effectRef>
+          <a:fontRef idx="minor">
+            <a:schemeClr val="lt1"/>
+          </a:fontRef>
+        </p:style>
+        <p:txBody>
+          <a:bodyPr rtlCol="0" anchor="ctr"/>
+          <a:lstStyle/>
+          <a:p/>
+        </p:txBody>
+      </p:sp>
+      <p:sp>
+        <p:nvSpPr>
+          <p:cNvPr id="12" name="TextBox 11"/>
+          <p:cNvSpPr txBox="1"/>
+          <p:nvPr/>
+        </p:nvSpPr>
+        <p:spPr>
+          <a:xfrm>
+            <a:off x="4453128" y="1746504"/>
+            <a:ext cx="3337560" cy="365760"/>
+          </a:xfrm>
+          <a:prstGeom prst="rect">
+            <a:avLst/>
+          </a:prstGeom>
+          <a:noFill/>
+        </p:spPr>
+        <p:txBody>
+          <a:bodyPr wrap="square" anchor="t" lIns="36576" rIns="36576" tIns="36576" bIns="36576">
+            <a:spAutoFit/>
+          </a:bodyPr>
+          <a:lstStyle/>
+          <a:p>
+            <a:pPr algn="l">
+              <a:lnSpc>
+                <a:spcPct val="100000"/>
+              </a:lnSpc>
+              <a:spcAft>
+                <a:spcPts val="0"/>
+              </a:spcAft>
+            </a:pPr>
+            <a:r>
+              <a:rPr sz="1450" b="0" i="0">
+                <a:solidFill>
+                  <a:srgbClr val="22D3EE"/>
+                </a:solidFill>
+                <a:latin typeface="Segoe UI Semibold"/>
+              </a:rPr>
+              <a:t>②  Microsoft Foundry agent</a:t>
+            </a:r>
+          </a:p>
+        </p:txBody>
+      </p:sp>
+      <p:sp>
+        <p:nvSpPr>
+          <p:cNvPr id="13" name="TextBox 12"/>
+          <p:cNvSpPr txBox="1"/>
+          <p:nvPr/>
+        </p:nvSpPr>
+        <p:spPr>
+          <a:xfrm>
+            <a:off x="4453128" y="2148840"/>
+            <a:ext cx="3337560" cy="1920240"/>
+          </a:xfrm>
+          <a:prstGeom prst="rect">
+            <a:avLst/>
+          </a:prstGeom>
+          <a:noFill/>
+        </p:spPr>
+        <p:txBody>
+          <a:bodyPr wrap="square" anchor="t" lIns="36576" rIns="36576" tIns="36576" bIns="36576">
+            <a:spAutoFit/>
+          </a:bodyPr>
+          <a:lstStyle/>
+          <a:p>
+            <a:pPr algn="l">
+              <a:lnSpc>
+                <a:spcPct val="100000"/>
+              </a:lnSpc>
+              <a:spcAft>
+                <a:spcPts val="500"/>
+              </a:spcAft>
+            </a:pPr>
+            <a:r>
+              <a:rPr sz="1050" b="0" i="0">
+                <a:solidFill>
+                  <a:srgbClr val="22D3EE"/>
+                </a:solidFill>
+                <a:latin typeface="Segoe UI"/>
+              </a:rPr>
+              <a:t>•  </a:t>
+            </a:r>
+            <a:r>
+              <a:rPr sz="1050" b="0" i="0">
+                <a:solidFill>
+                  <a:srgbClr val="F5F6FA"/>
+                </a:solidFill>
+                <a:latin typeface="Segoe UI"/>
+              </a:rPr>
+              <a:t>Not in the Foundry model catalog - you bring your own TypeSafe key.</a:t>
+            </a:r>
+          </a:p>
+          <a:p>
+            <a:pPr algn="l">
+              <a:lnSpc>
+                <a:spcPct val="100000"/>
+              </a:lnSpc>
+              <a:spcAft>
+                <a:spcPts val="500"/>
+              </a:spcAft>
+            </a:pPr>
+            <a:r>
+              <a:rPr sz="1050" b="0" i="0">
+                <a:solidFill>
+                  <a:srgbClr val="22D3EE"/>
+                </a:solidFill>
+                <a:latin typeface="Segoe UI"/>
+              </a:rPr>
+              <a:t>•  </a:t>
+            </a:r>
+            <a:r>
+              <a:rPr sz="1050" b="0" i="0">
+                <a:solidFill>
+                  <a:srgbClr val="F5F6FA"/>
+                </a:solidFill>
+                <a:latin typeface="Segoe UI"/>
+              </a:rPr>
+              <a:t>Add an OpenAPI tool “evaluate_with_jev” (POST /v1/systemone) with a “Bearer &lt;key&gt;” connection.</a:t>
+            </a:r>
+          </a:p>
+          <a:p>
+            <a:pPr algn="l">
+              <a:lnSpc>
+                <a:spcPct val="100000"/>
+              </a:lnSpc>
+              <a:spcAft>
+                <a:spcPts val="500"/>
+              </a:spcAft>
+            </a:pPr>
+            <a:r>
+              <a:rPr sz="1050" b="0" i="0">
+                <a:solidFill>
+                  <a:srgbClr val="22D3EE"/>
+                </a:solidFill>
+                <a:latin typeface="Segoe UI"/>
+              </a:rPr>
+              <a:t>•  </a:t>
+            </a:r>
+            <a:r>
+              <a:rPr sz="1050" b="0" i="0">
+                <a:solidFill>
+                  <a:srgbClr val="F5F6FA"/>
+                </a:solidFill>
+                <a:latin typeface="Segoe UI"/>
+              </a:rPr>
+              <a:t>Agent instructions: always call Jev, use its values, never classify on its own.</a:t>
+            </a:r>
+          </a:p>
+          <a:p>
+            <a:pPr algn="l">
+              <a:lnSpc>
+                <a:spcPct val="100000"/>
+              </a:lnSpc>
+              <a:spcAft>
+                <a:spcPts val="500"/>
+              </a:spcAft>
+            </a:pPr>
+            <a:r>
+              <a:rPr sz="1050" b="0" i="0">
+                <a:solidFill>
+                  <a:srgbClr val="22D3EE"/>
+                </a:solidFill>
+                <a:latin typeface="Segoe UI"/>
+              </a:rPr>
+              <a:t>•  </a:t>
+            </a:r>
+            <a:r>
+              <a:rPr sz="1050" b="0" i="0">
+                <a:solidFill>
+                  <a:srgbClr val="F5F6FA"/>
+                </a:solidFill>
+                <a:latin typeface="Segoe UI"/>
+              </a:rPr>
+              <a:t>“The room had no water and a towel was dirty” → billing 0.02 · tone frustrated (.74) · urgency 1.81 → handle today.</a:t>
+            </a:r>
+          </a:p>
+        </p:txBody>
+      </p:sp>
+      <p:sp>
+        <p:nvSpPr>
+          <p:cNvPr id="14" name="TextBox 13">
+            <a:hlinkClick r:id="rId3"/>
+          </p:cNvPr>
+          <p:cNvSpPr txBox="1"/>
+          <p:nvPr/>
+        </p:nvSpPr>
+        <p:spPr>
+          <a:xfrm>
+            <a:off x="4453128" y="4069079"/>
+            <a:ext cx="3337560" cy="292608"/>
+          </a:xfrm>
+          <a:prstGeom prst="rect">
+            <a:avLst/>
+          </a:prstGeom>
+          <a:noFill/>
+        </p:spPr>
+        <p:txBody>
+          <a:bodyPr wrap="square" anchor="t" lIns="36576" rIns="36576" tIns="36576" bIns="36576">
+            <a:spAutoFit/>
+          </a:bodyPr>
+          <a:lstStyle/>
+          <a:p>
+            <a:pPr algn="l">
+              <a:lnSpc>
+                <a:spcPct val="100000"/>
+              </a:lnSpc>
+              <a:spcAft>
+                <a:spcPts val="0"/>
+              </a:spcAft>
+            </a:pPr>
+            <a:r>
+              <a:rPr sz="1000" b="0" i="0" u="sng">
+                <a:solidFill>
+                  <a:srgbClr val="22D3EE"/>
+                </a:solidFill>
+                <a:latin typeface="Segoe UI Semibold"/>
+              </a:rPr>
+              <a:t>Microsoft Tech Community article</a:t>
+            </a:r>
+          </a:p>
+        </p:txBody>
+      </p:sp>
+      <p:sp>
+        <p:nvSpPr>
+          <p:cNvPr id="15" name="Rounded Rectangle 14"/>
+          <p:cNvSpPr/>
+          <p:nvPr/>
+        </p:nvSpPr>
+        <p:spPr>
+          <a:xfrm>
+            <a:off x="8119872" y="1600200"/>
+            <a:ext cx="3611880" cy="2834640"/>
+          </a:xfrm>
+          <a:prstGeom prst="roundRect">
+            <a:avLst>
+              <a:gd name="adj" fmla="val 6000"/>
+            </a:avLst>
+          </a:prstGeom>
+          <a:solidFill>
+            <a:srgbClr val="1A1D27"/>
+          </a:solidFill>
+          <a:ln>
+            <a:noFill/>
+          </a:ln>
+          <a:effectLst/>
+        </p:spPr>
+        <p:style>
+          <a:lnRef idx="1">
+            <a:schemeClr val="accent1"/>
+          </a:lnRef>
+          <a:fillRef idx="3">
+            <a:schemeClr val="accent1"/>
+          </a:fillRef>
+          <a:effectRef idx="2">
+            <a:schemeClr val="accent1"/>
+          </a:effectRef>
+          <a:fontRef idx="minor">
+            <a:schemeClr val="lt1"/>
+          </a:fontRef>
+        </p:style>
+        <p:txBody>
+          <a:bodyPr rtlCol="0" anchor="ctr"/>
+          <a:lstStyle/>
+          <a:p/>
+        </p:txBody>
+      </p:sp>
+      <p:sp>
+        <p:nvSpPr>
+          <p:cNvPr id="16" name="Rectangle 15"/>
+          <p:cNvSpPr/>
+          <p:nvPr/>
+        </p:nvSpPr>
+        <p:spPr>
+          <a:xfrm>
+            <a:off x="8119872" y="1600200"/>
+            <a:ext cx="3611880" cy="64008"/>
+          </a:xfrm>
+          <a:prstGeom prst="rect">
+            <a:avLst/>
+          </a:prstGeom>
+          <a:solidFill>
+            <a:srgbClr val="34D399"/>
+          </a:solidFill>
+          <a:ln>
+            <a:noFill/>
+          </a:ln>
+          <a:effectLst/>
+        </p:spPr>
+        <p:style>
+          <a:lnRef idx="1">
+            <a:schemeClr val="accent1"/>
+          </a:lnRef>
+          <a:fillRef idx="3">
+            <a:schemeClr val="accent1"/>
+          </a:fillRef>
+          <a:effectRef idx="2">
+            <a:schemeClr val="accent1"/>
+          </a:effectRef>
+          <a:fontRef idx="minor">
+            <a:schemeClr val="lt1"/>
+          </a:fontRef>
+        </p:style>
+        <p:txBody>
+          <a:bodyPr rtlCol="0" anchor="ctr"/>
+          <a:lstStyle/>
+          <a:p/>
+        </p:txBody>
+      </p:sp>
+      <p:sp>
+        <p:nvSpPr>
+          <p:cNvPr id="17" name="TextBox 16"/>
+          <p:cNvSpPr txBox="1"/>
+          <p:nvPr/>
+        </p:nvSpPr>
+        <p:spPr>
+          <a:xfrm>
+            <a:off x="8284464" y="1746504"/>
+            <a:ext cx="3337560" cy="365760"/>
+          </a:xfrm>
+          <a:prstGeom prst="rect">
+            <a:avLst/>
+          </a:prstGeom>
+          <a:noFill/>
+        </p:spPr>
+        <p:txBody>
+          <a:bodyPr wrap="square" anchor="t" lIns="36576" rIns="36576" tIns="36576" bIns="36576">
+            <a:spAutoFit/>
+          </a:bodyPr>
+          <a:lstStyle/>
+          <a:p>
+            <a:pPr algn="l">
+              <a:lnSpc>
+                <a:spcPct val="100000"/>
+              </a:lnSpc>
+              <a:spcAft>
+                <a:spcPts val="0"/>
+              </a:spcAft>
+            </a:pPr>
+            <a:r>
+              <a:rPr sz="1450" b="0" i="0">
+                <a:solidFill>
+                  <a:srgbClr val="34D399"/>
+                </a:solidFill>
+                <a:latin typeface="Segoe UI Semibold"/>
+              </a:rPr>
+              <a:t>③  Open-source Laya  (no sign-up)</a:t>
+            </a:r>
+          </a:p>
+        </p:txBody>
+      </p:sp>
+      <p:sp>
+        <p:nvSpPr>
+          <p:cNvPr id="18" name="TextBox 17"/>
+          <p:cNvSpPr txBox="1"/>
+          <p:nvPr/>
+        </p:nvSpPr>
+        <p:spPr>
+          <a:xfrm>
+            <a:off x="8284464" y="2148840"/>
+            <a:ext cx="3337560" cy="1920240"/>
+          </a:xfrm>
+          <a:prstGeom prst="rect">
+            <a:avLst/>
+          </a:prstGeom>
+          <a:noFill/>
+        </p:spPr>
+        <p:txBody>
+          <a:bodyPr wrap="square" anchor="t" lIns="36576" rIns="36576" tIns="36576" bIns="36576">
+            <a:spAutoFit/>
+          </a:bodyPr>
+          <a:lstStyle/>
+          <a:p>
+            <a:pPr algn="l">
+              <a:lnSpc>
+                <a:spcPct val="100000"/>
+              </a:lnSpc>
+              <a:spcAft>
+                <a:spcPts val="500"/>
+              </a:spcAft>
+            </a:pPr>
+            <a:r>
+              <a:rPr sz="1050" b="0" i="0">
+                <a:solidFill>
+                  <a:srgbClr val="34D399"/>
+                </a:solidFill>
+                <a:latin typeface="Segoe UI"/>
+              </a:rPr>
+              <a:t>•  </a:t>
+            </a:r>
+            <a:r>
+              <a:rPr sz="1050" b="0" i="0">
+                <a:solidFill>
+                  <a:srgbClr val="F5F6FA"/>
+                </a:solidFill>
+                <a:latin typeface="Segoe UI"/>
+              </a:rPr>
+              <a:t>Apache-2.0, 421M params, runs on a laptop CPU (~0.3 s per question; ~33 ms on a T4 GPU).</a:t>
+            </a:r>
+          </a:p>
+          <a:p>
+            <a:pPr algn="l">
+              <a:lnSpc>
+                <a:spcPct val="100000"/>
+              </a:lnSpc>
+              <a:spcAft>
+                <a:spcPts val="500"/>
+              </a:spcAft>
+            </a:pPr>
+            <a:r>
+              <a:rPr sz="1050" b="0" i="0">
+                <a:solidFill>
+                  <a:srgbClr val="34D399"/>
+                </a:solidFill>
+                <a:latin typeface="Segoe UI"/>
+              </a:rPr>
+              <a:t>•  </a:t>
+            </a:r>
+            <a:r>
+              <a:rPr sz="1050" b="0" i="0">
+                <a:solidFill>
+                  <a:srgbClr val="F5F6FA"/>
+                </a:solidFill>
+                <a:latin typeface="Segoe UI"/>
+              </a:rPr>
+              <a:t>Same state + questions → typed answers; laya-serve exposes /v1/systemone.</a:t>
+            </a:r>
+          </a:p>
+          <a:p>
+            <a:pPr algn="l">
+              <a:lnSpc>
+                <a:spcPct val="100000"/>
+              </a:lnSpc>
+              <a:spcAft>
+                <a:spcPts val="500"/>
+              </a:spcAft>
+            </a:pPr>
+            <a:r>
+              <a:rPr sz="1050" b="0" i="0">
+                <a:solidFill>
+                  <a:srgbClr val="34D399"/>
+                </a:solidFill>
+                <a:latin typeface="Segoe UI"/>
+              </a:rPr>
+              <a:t>•  </a:t>
+            </a:r>
+            <a:r>
+              <a:rPr sz="1050" b="0" i="0">
+                <a:solidFill>
+                  <a:srgbClr val="F5F6FA"/>
+                </a:solidFill>
+                <a:latin typeface="Segoe UI"/>
+              </a:rPr>
+              <a:t>Zero-shot quality is lower than Jev: test wording, fine-tune for production.</a:t>
+            </a:r>
+          </a:p>
+          <a:p>
+            <a:pPr algn="l">
+              <a:lnSpc>
+                <a:spcPct val="100000"/>
+              </a:lnSpc>
+              <a:spcAft>
+                <a:spcPts val="500"/>
+              </a:spcAft>
+            </a:pPr>
+            <a:r>
+              <a:rPr sz="1050" b="0" i="0">
+                <a:solidFill>
+                  <a:srgbClr val="34D399"/>
+                </a:solidFill>
+                <a:latin typeface="Segoe UI"/>
+              </a:rPr>
+              <a:t>•  </a:t>
+            </a:r>
+            <a:r>
+              <a:rPr sz="1050" b="0" i="0">
+                <a:solidFill>
+                  <a:srgbClr val="F5F6FA"/>
+                </a:solidFill>
+                <a:latin typeface="Segoe UI"/>
+              </a:rPr>
+              <a:t>Powers all our samples and UI demos.</a:t>
+            </a:r>
+          </a:p>
+        </p:txBody>
+      </p:sp>
+      <p:sp>
+        <p:nvSpPr>
+          <p:cNvPr id="19" name="TextBox 18">
+            <a:hlinkClick r:id="rId4"/>
+          </p:cNvPr>
+          <p:cNvSpPr txBox="1"/>
+          <p:nvPr/>
+        </p:nvSpPr>
+        <p:spPr>
+          <a:xfrm>
+            <a:off x="8284464" y="4069079"/>
+            <a:ext cx="3337560" cy="292608"/>
+          </a:xfrm>
+          <a:prstGeom prst="rect">
+            <a:avLst/>
+          </a:prstGeom>
+          <a:noFill/>
+        </p:spPr>
+        <p:txBody>
+          <a:bodyPr wrap="square" anchor="t" lIns="36576" rIns="36576" tIns="36576" bIns="36576">
+            <a:spAutoFit/>
+          </a:bodyPr>
+          <a:lstStyle/>
+          <a:p>
+            <a:pPr algn="l">
+              <a:lnSpc>
+                <a:spcPct val="100000"/>
+              </a:lnSpc>
+              <a:spcAft>
+                <a:spcPts val="0"/>
+              </a:spcAft>
+            </a:pPr>
+            <a:r>
+              <a:rPr sz="1000" b="0" i="0" u="sng">
+                <a:solidFill>
+                  <a:srgbClr val="34D399"/>
+                </a:solidFill>
+                <a:latin typeface="Segoe UI Semibold"/>
+              </a:rPr>
+              <a:t>huggingface.co/convaiinnovations/laya</a:t>
+            </a:r>
+          </a:p>
+        </p:txBody>
+      </p:sp>
+      <p:sp>
+        <p:nvSpPr>
+          <p:cNvPr id="20" name="Rounded Rectangle 19"/>
+          <p:cNvSpPr/>
+          <p:nvPr/>
+        </p:nvSpPr>
+        <p:spPr>
+          <a:xfrm>
+            <a:off x="457200" y="4617720"/>
+            <a:ext cx="6812280" cy="1874519"/>
+          </a:xfrm>
+          <a:prstGeom prst="roundRect">
+            <a:avLst>
+              <a:gd name="adj" fmla="val 6000"/>
+            </a:avLst>
+          </a:prstGeom>
+          <a:solidFill>
+            <a:srgbClr val="1A1D27"/>
+          </a:solidFill>
+          <a:ln>
+            <a:noFill/>
+          </a:ln>
+          <a:effectLst/>
+        </p:spPr>
+        <p:style>
+          <a:lnRef idx="1">
+            <a:schemeClr val="accent1"/>
+          </a:lnRef>
+          <a:fillRef idx="3">
+            <a:schemeClr val="accent1"/>
+          </a:fillRef>
+          <a:effectRef idx="2">
+            <a:schemeClr val="accent1"/>
+          </a:effectRef>
+          <a:fontRef idx="minor">
+            <a:schemeClr val="lt1"/>
+          </a:fontRef>
+        </p:style>
+        <p:txBody>
+          <a:bodyPr rtlCol="0" anchor="ctr"/>
+          <a:lstStyle/>
+          <a:p/>
+        </p:txBody>
+      </p:sp>
+      <p:sp>
+        <p:nvSpPr>
+          <p:cNvPr id="21" name="TextBox 20"/>
+          <p:cNvSpPr txBox="1"/>
+          <p:nvPr/>
+        </p:nvSpPr>
+        <p:spPr>
+          <a:xfrm>
+            <a:off x="621792" y="4690872"/>
+            <a:ext cx="6583680" cy="274320"/>
+          </a:xfrm>
+          <a:prstGeom prst="rect">
+            <a:avLst/>
+          </a:prstGeom>
+          <a:noFill/>
+        </p:spPr>
+        <p:txBody>
+          <a:bodyPr wrap="square" anchor="t" lIns="36576" rIns="36576" tIns="36576" bIns="36576">
+            <a:spAutoFit/>
+          </a:bodyPr>
+          <a:lstStyle/>
+          <a:p>
+            <a:pPr algn="l">
+              <a:lnSpc>
+                <a:spcPct val="100000"/>
+              </a:lnSpc>
+              <a:spcAft>
+                <a:spcPts val="0"/>
+              </a:spcAft>
+            </a:pPr>
+            <a:r>
+              <a:rPr sz="1200" b="0" i="0">
+                <a:solidFill>
+                  <a:srgbClr val="F5F6FA"/>
+                </a:solidFill>
+                <a:latin typeface="Segoe UI Semibold"/>
+              </a:rPr>
+              <a:t>Pattern from the Foundry article: </a:t>
+            </a:r>
+            <a:r>
+              <a:rPr sz="1200" b="0" i="0">
+                <a:solidFill>
+                  <a:srgbClr val="A3A9BC"/>
+                </a:solidFill>
+                <a:latin typeface="Segoe UI"/>
+              </a:rPr>
+              <a:t>Jev as a judgement layer</a:t>
+            </a:r>
+          </a:p>
+        </p:txBody>
+      </p:sp>
+      <p:sp>
+        <p:nvSpPr>
+          <p:cNvPr id="22" name="Pentagon 21"/>
+          <p:cNvSpPr/>
+          <p:nvPr/>
+        </p:nvSpPr>
+        <p:spPr>
+          <a:xfrm>
+            <a:off x="621792" y="5074920"/>
+            <a:ext cx="1417320" cy="640080"/>
+          </a:xfrm>
+          <a:prstGeom prst="homePlate">
+            <a:avLst/>
+          </a:prstGeom>
+          <a:solidFill>
+            <a:srgbClr val="242836"/>
+          </a:solidFill>
+          <a:ln>
+            <a:noFill/>
+          </a:ln>
+          <a:effectLst/>
+        </p:spPr>
+        <p:style>
+          <a:lnRef idx="1">
+            <a:schemeClr val="accent1"/>
+          </a:lnRef>
+          <a:fillRef idx="3">
+            <a:schemeClr val="accent1"/>
+          </a:fillRef>
+          <a:effectRef idx="2">
+            <a:schemeClr val="accent1"/>
+          </a:effectRef>
+          <a:fontRef idx="minor">
+            <a:schemeClr val="lt1"/>
+          </a:fontRef>
+        </p:style>
+        <p:txBody>
+          <a:bodyPr rtlCol="0" anchor="ctr" wrap="square" lIns="36576" rIns="36576" tIns="36576" bIns="36576"/>
+          <a:lstStyle/>
+          <a:p>
+            <a:pPr algn="ctr">
+              <a:lnSpc>
+                <a:spcPct val="100000"/>
+              </a:lnSpc>
+              <a:spcAft>
+                <a:spcPts val="0"/>
+              </a:spcAft>
+            </a:pPr>
+            <a:r>
+              <a:rPr sz="950" b="0" i="0">
+                <a:solidFill>
+                  <a:srgbClr val="F5F6FA"/>
+                </a:solidFill>
+                <a:latin typeface="Segoe UI"/>
+              </a:rPr>
+              <a:t>User / app</a:t>
+            </a:r>
+          </a:p>
+        </p:txBody>
+      </p:sp>
+      <p:sp>
+        <p:nvSpPr>
+          <p:cNvPr id="23" name="Chevron 22"/>
+          <p:cNvSpPr/>
+          <p:nvPr/>
+        </p:nvSpPr>
+        <p:spPr>
+          <a:xfrm>
+            <a:off x="1920240" y="5074920"/>
+            <a:ext cx="1417320" cy="640080"/>
+          </a:xfrm>
+          <a:prstGeom prst="chevron">
+            <a:avLst/>
+          </a:prstGeom>
+          <a:solidFill>
+            <a:srgbClr val="242836"/>
+          </a:solidFill>
+          <a:ln>
+            <a:noFill/>
+          </a:ln>
+          <a:effectLst/>
+        </p:spPr>
+        <p:style>
+          <a:lnRef idx="1">
+            <a:schemeClr val="accent1"/>
+          </a:lnRef>
+          <a:fillRef idx="3">
+            <a:schemeClr val="accent1"/>
+          </a:fillRef>
+          <a:effectRef idx="2">
+            <a:schemeClr val="accent1"/>
+          </a:effectRef>
+          <a:fontRef idx="minor">
+            <a:schemeClr val="lt1"/>
+          </a:fontRef>
+        </p:style>
+        <p:txBody>
+          <a:bodyPr rtlCol="0" anchor="ctr" wrap="square" lIns="36576" rIns="36576" tIns="36576" bIns="36576"/>
+          <a:lstStyle/>
+          <a:p>
+            <a:pPr algn="ctr">
+              <a:lnSpc>
+                <a:spcPct val="100000"/>
+              </a:lnSpc>
+              <a:spcAft>
+                <a:spcPts val="0"/>
+              </a:spcAft>
+            </a:pPr>
+            <a:r>
+              <a:rPr sz="950" b="0" i="0">
+                <a:solidFill>
+                  <a:srgbClr val="F5F6FA"/>
+                </a:solidFill>
+                <a:latin typeface="Segoe UI"/>
+              </a:rPr>
+              <a:t>Foundry agent
+or model</a:t>
+            </a:r>
+          </a:p>
+        </p:txBody>
+      </p:sp>
+      <p:sp>
+        <p:nvSpPr>
+          <p:cNvPr id="24" name="Chevron 23"/>
+          <p:cNvSpPr/>
+          <p:nvPr/>
+        </p:nvSpPr>
+        <p:spPr>
+          <a:xfrm>
+            <a:off x="3218688" y="5074920"/>
+            <a:ext cx="1417320" cy="640080"/>
+          </a:xfrm>
+          <a:prstGeom prst="chevron">
+            <a:avLst/>
+          </a:prstGeom>
+          <a:solidFill>
+            <a:srgbClr val="22D3EE"/>
+          </a:solidFill>
+          <a:ln>
+            <a:noFill/>
+          </a:ln>
+          <a:effectLst/>
+        </p:spPr>
+        <p:style>
+          <a:lnRef idx="1">
+            <a:schemeClr val="accent1"/>
+          </a:lnRef>
+          <a:fillRef idx="3">
+            <a:schemeClr val="accent1"/>
+          </a:fillRef>
+          <a:effectRef idx="2">
+            <a:schemeClr val="accent1"/>
+          </a:effectRef>
+          <a:fontRef idx="minor">
+            <a:schemeClr val="lt1"/>
+          </a:fontRef>
+        </p:style>
+        <p:txBody>
+          <a:bodyPr rtlCol="0" anchor="ctr" wrap="square" lIns="36576" rIns="36576" tIns="36576" bIns="36576"/>
+          <a:lstStyle/>
+          <a:p>
+            <a:pPr algn="ctr">
+              <a:lnSpc>
+                <a:spcPct val="100000"/>
+              </a:lnSpc>
+              <a:spcAft>
+                <a:spcPts val="0"/>
+              </a:spcAft>
+            </a:pPr>
+            <a:r>
+              <a:rPr sz="950" b="0" i="0">
+                <a:solidFill>
+                  <a:srgbClr val="0F1117"/>
+                </a:solidFill>
+                <a:latin typeface="Segoe UI Semibold"/>
+              </a:rPr>
+              <a:t>Jev judgement</a:t>
+            </a:r>
+          </a:p>
+        </p:txBody>
+      </p:sp>
+      <p:sp>
+        <p:nvSpPr>
+          <p:cNvPr id="25" name="Chevron 24"/>
+          <p:cNvSpPr/>
+          <p:nvPr/>
+        </p:nvSpPr>
+        <p:spPr>
+          <a:xfrm>
+            <a:off x="4517136" y="5074920"/>
+            <a:ext cx="1417320" cy="640080"/>
+          </a:xfrm>
+          <a:prstGeom prst="chevron">
+            <a:avLst/>
+          </a:prstGeom>
+          <a:solidFill>
+            <a:srgbClr val="242836"/>
+          </a:solidFill>
+          <a:ln>
+            <a:noFill/>
+          </a:ln>
+          <a:effectLst/>
+        </p:spPr>
+        <p:style>
+          <a:lnRef idx="1">
+            <a:schemeClr val="accent1"/>
+          </a:lnRef>
+          <a:fillRef idx="3">
+            <a:schemeClr val="accent1"/>
+          </a:fillRef>
+          <a:effectRef idx="2">
+            <a:schemeClr val="accent1"/>
+          </a:effectRef>
+          <a:fontRef idx="minor">
+            <a:schemeClr val="lt1"/>
+          </a:fontRef>
+        </p:style>
+        <p:txBody>
+          <a:bodyPr rtlCol="0" anchor="ctr" wrap="square" lIns="36576" rIns="36576" tIns="36576" bIns="36576"/>
+          <a:lstStyle/>
+          <a:p>
+            <a:pPr algn="ctr">
+              <a:lnSpc>
+                <a:spcPct val="100000"/>
+              </a:lnSpc>
+              <a:spcAft>
+                <a:spcPts val="0"/>
+              </a:spcAft>
+            </a:pPr>
+            <a:r>
+              <a:rPr sz="950" b="0" i="0">
+                <a:solidFill>
+                  <a:srgbClr val="F5F6FA"/>
+                </a:solidFill>
+                <a:latin typeface="Segoe UI"/>
+              </a:rPr>
+              <a:t>Business rules
+(code)</a:t>
+            </a:r>
+          </a:p>
+        </p:txBody>
+      </p:sp>
+      <p:sp>
+        <p:nvSpPr>
+          <p:cNvPr id="26" name="Chevron 25"/>
+          <p:cNvSpPr/>
+          <p:nvPr/>
+        </p:nvSpPr>
+        <p:spPr>
+          <a:xfrm>
+            <a:off x="5815583" y="5074920"/>
+            <a:ext cx="1417320" cy="640080"/>
+          </a:xfrm>
+          <a:prstGeom prst="chevron">
+            <a:avLst/>
+          </a:prstGeom>
+          <a:solidFill>
+            <a:srgbClr val="242836"/>
+          </a:solidFill>
+          <a:ln>
+            <a:noFill/>
+          </a:ln>
+          <a:effectLst/>
+        </p:spPr>
+        <p:style>
+          <a:lnRef idx="1">
+            <a:schemeClr val="accent1"/>
+          </a:lnRef>
+          <a:fillRef idx="3">
+            <a:schemeClr val="accent1"/>
+          </a:fillRef>
+          <a:effectRef idx="2">
+            <a:schemeClr val="accent1"/>
+          </a:effectRef>
+          <a:fontRef idx="minor">
+            <a:schemeClr val="lt1"/>
+          </a:fontRef>
+        </p:style>
+        <p:txBody>
+          <a:bodyPr rtlCol="0" anchor="ctr" wrap="square" lIns="36576" rIns="36576" tIns="36576" bIns="36576"/>
+          <a:lstStyle/>
+          <a:p>
+            <a:pPr algn="ctr">
+              <a:lnSpc>
+                <a:spcPct val="100000"/>
+              </a:lnSpc>
+              <a:spcAft>
+                <a:spcPts val="0"/>
+              </a:spcAft>
+            </a:pPr>
+            <a:r>
+              <a:rPr sz="950" b="0" i="0">
+                <a:solidFill>
+                  <a:srgbClr val="F5F6FA"/>
+                </a:solidFill>
+                <a:latin typeface="Segoe UI"/>
+              </a:rPr>
+              <a:t>Action /
+response</a:t>
+            </a:r>
+          </a:p>
+        </p:txBody>
+      </p:sp>
+      <p:sp>
+        <p:nvSpPr>
+          <p:cNvPr id="27" name="TextBox 26"/>
+          <p:cNvSpPr txBox="1"/>
+          <p:nvPr/>
+        </p:nvSpPr>
+        <p:spPr>
+          <a:xfrm>
+            <a:off x="621792" y="5806440"/>
+            <a:ext cx="6537960" cy="685800"/>
+          </a:xfrm>
+          <a:prstGeom prst="rect">
+            <a:avLst/>
+          </a:prstGeom>
+          <a:noFill/>
+        </p:spPr>
+        <p:txBody>
+          <a:bodyPr wrap="square" anchor="t" lIns="36576" rIns="36576" tIns="36576" bIns="36576">
+            <a:spAutoFit/>
+          </a:bodyPr>
+          <a:lstStyle/>
+          <a:p>
+            <a:pPr algn="l">
+              <a:lnSpc>
+                <a:spcPct val="100000"/>
+              </a:lnSpc>
+              <a:spcAft>
+                <a:spcPts val="0"/>
+              </a:spcAft>
+            </a:pPr>
+            <a:r>
+              <a:rPr sz="1050" b="0" i="0">
+                <a:solidFill>
+                  <a:srgbClr val="F5F6FA"/>
+                </a:solidFill>
+                <a:latin typeface="Segoe UI Semibold"/>
+              </a:rPr>
+              <a:t>Explainability for Model-as-a-Service: </a:t>
+            </a:r>
+            <a:r>
+              <a:rPr sz="1050" b="0" i="0">
+                <a:solidFill>
+                  <a:srgbClr val="A3A9BC"/>
+                </a:solidFill>
+                <a:latin typeface="Segoe UI"/>
+              </a:rPr>
+              <a:t>not SHAP-style feature attribution, but a measurable layer that checks an opaque hosted LLM's inputs, outputs and proposed actions against explicit criteria - with a confidence to gate on.</a:t>
+            </a:r>
+          </a:p>
+        </p:txBody>
+      </p:sp>
+      <p:sp>
+        <p:nvSpPr>
+          <p:cNvPr id="28" name="Rounded Rectangle 27"/>
+          <p:cNvSpPr/>
+          <p:nvPr/>
+        </p:nvSpPr>
+        <p:spPr>
+          <a:xfrm>
+            <a:off x="7452360" y="4617720"/>
+            <a:ext cx="4279392" cy="1874519"/>
+          </a:xfrm>
+          <a:prstGeom prst="roundRect">
+            <a:avLst>
+              <a:gd name="adj" fmla="val 6000"/>
+            </a:avLst>
+          </a:prstGeom>
+          <a:solidFill>
+            <a:srgbClr val="1A1D27"/>
+          </a:solidFill>
+          <a:ln w="15875">
+            <a:solidFill>
+              <a:srgbClr val="34D399"/>
+            </a:solidFill>
+          </a:ln>
+          <a:effectLst/>
+        </p:spPr>
+        <p:style>
+          <a:lnRef idx="1">
+            <a:schemeClr val="accent1"/>
+          </a:lnRef>
+          <a:fillRef idx="3">
+            <a:schemeClr val="accent1"/>
+          </a:fillRef>
+          <a:effectRef idx="2">
+            <a:schemeClr val="accent1"/>
+          </a:effectRef>
+          <a:fontRef idx="minor">
+            <a:schemeClr val="lt1"/>
+          </a:fontRef>
+        </p:style>
+        <p:txBody>
+          <a:bodyPr rtlCol="0" anchor="ctr"/>
+          <a:lstStyle/>
+          <a:p/>
+        </p:txBody>
+      </p:sp>
+      <p:sp>
+        <p:nvSpPr>
+          <p:cNvPr id="29" name="TextBox 28">
+            <a:hlinkClick r:id="rId5"/>
+          </p:cNvPr>
+          <p:cNvSpPr txBox="1"/>
+          <p:nvPr/>
+        </p:nvSpPr>
+        <p:spPr>
+          <a:xfrm>
+            <a:off x="7589520" y="4681728"/>
+            <a:ext cx="4023360" cy="292608"/>
+          </a:xfrm>
+          <a:prstGeom prst="rect">
+            <a:avLst/>
+          </a:prstGeom>
+          <a:noFill/>
+        </p:spPr>
+        <p:txBody>
+          <a:bodyPr wrap="square" anchor="t" lIns="36576" rIns="36576" tIns="36576" bIns="36576">
+            <a:spAutoFit/>
+          </a:bodyPr>
+          <a:lstStyle/>
+          <a:p>
+            <a:pPr algn="l">
+              <a:lnSpc>
+                <a:spcPct val="100000"/>
+              </a:lnSpc>
+              <a:spcAft>
+                <a:spcPts val="0"/>
+              </a:spcAft>
+            </a:pPr>
+            <a:r>
+              <a:rPr sz="1150" b="0" i="0">
+                <a:solidFill>
+                  <a:srgbClr val="A3A9BC"/>
+                </a:solidFill>
+                <a:latin typeface="Segoe UI"/>
+              </a:rPr>
+              <a:t>Run our samples:  </a:t>
+            </a:r>
+            <a:r>
+              <a:rPr sz="1150" b="0" i="0" u="sng">
+                <a:solidFill>
+                  <a:srgbClr val="34D399"/>
+                </a:solidFill>
+                <a:latin typeface="Segoe UI Semibold"/>
+              </a:rPr>
+              <a:t>github.com/stvonolf/jev-samples</a:t>
+            </a:r>
+          </a:p>
+        </p:txBody>
+      </p:sp>
+      <p:sp>
+        <p:nvSpPr>
+          <p:cNvPr id="30" name="TextBox 29"/>
+          <p:cNvSpPr txBox="1"/>
+          <p:nvPr/>
+        </p:nvSpPr>
+        <p:spPr>
+          <a:xfrm>
+            <a:off x="7589520" y="5029200"/>
+            <a:ext cx="4069080" cy="1463040"/>
+          </a:xfrm>
+          <a:prstGeom prst="rect">
+            <a:avLst/>
+          </a:prstGeom>
+          <a:noFill/>
+        </p:spPr>
+        <p:txBody>
+          <a:bodyPr wrap="square" anchor="t" lIns="36576" rIns="36576" tIns="36576" bIns="36576">
+            <a:spAutoFit/>
+          </a:bodyPr>
+          <a:lstStyle/>
+          <a:p>
+            <a:pPr algn="l">
+              <a:lnSpc>
+                <a:spcPct val="110000"/>
+              </a:lnSpc>
+              <a:spcAft>
+                <a:spcPts val="0"/>
+              </a:spcAft>
+            </a:pPr>
+            <a:r>
+              <a:rPr sz="900" b="0" i="0">
+                <a:solidFill>
+                  <a:srgbClr val="F5F6FA"/>
+                </a:solidFill>
+                <a:latin typeface="Consolas"/>
+              </a:rPr>
+              <a:t>git clone https://github.com/stvonolf/jev-samples</a:t>
+            </a:r>
+          </a:p>
+          <a:p>
+            <a:pPr algn="l">
+              <a:lnSpc>
+                <a:spcPct val="110000"/>
+              </a:lnSpc>
+              <a:spcAft>
+                <a:spcPts val="0"/>
+              </a:spcAft>
+            </a:pPr>
+            <a:r>
+              <a:rPr sz="900" b="0" i="0">
+                <a:solidFill>
+                  <a:srgbClr val="F5F6FA"/>
+                </a:solidFill>
+                <a:latin typeface="Consolas"/>
+              </a:rPr>
+              <a:t>cd jev-samples</a:t>
+            </a:r>
+          </a:p>
+          <a:p>
+            <a:pPr algn="l">
+              <a:lnSpc>
+                <a:spcPct val="110000"/>
+              </a:lnSpc>
+              <a:spcAft>
+                <a:spcPts val="0"/>
+              </a:spcAft>
+            </a:pPr>
+            <a:r>
+              <a:rPr sz="900" b="0" i="0">
+                <a:solidFill>
+                  <a:srgbClr val="F5F6FA"/>
+                </a:solidFill>
+                <a:latin typeface="Consolas"/>
+              </a:rPr>
+              <a:t>python -m venv .venv</a:t>
+            </a:r>
+          </a:p>
+          <a:p>
+            <a:pPr algn="l">
+              <a:lnSpc>
+                <a:spcPct val="110000"/>
+              </a:lnSpc>
+              <a:spcAft>
+                <a:spcPts val="0"/>
+              </a:spcAft>
+            </a:pPr>
+            <a:r>
+              <a:rPr sz="900" b="0" i="0">
+                <a:solidFill>
+                  <a:srgbClr val="F5F6FA"/>
+                </a:solidFill>
+                <a:latin typeface="Consolas"/>
+              </a:rPr>
+              <a:t>.venv\Scripts\pip install -r samples\requirements.txt</a:t>
+            </a:r>
+          </a:p>
+          <a:p>
+            <a:pPr algn="l">
+              <a:lnSpc>
+                <a:spcPct val="110000"/>
+              </a:lnSpc>
+              <a:spcAft>
+                <a:spcPts val="0"/>
+              </a:spcAft>
+            </a:pPr>
+            <a:r>
+              <a:rPr sz="900" b="0" i="0">
+                <a:solidFill>
+                  <a:srgbClr val="F5F6FA"/>
+                </a:solidFill>
+                <a:latin typeface="Consolas"/>
+              </a:rPr>
+              <a:t>cd samples</a:t>
+            </a:r>
+          </a:p>
+          <a:p>
+            <a:pPr algn="l">
+              <a:lnSpc>
+                <a:spcPct val="110000"/>
+              </a:lnSpc>
+              <a:spcAft>
+                <a:spcPts val="0"/>
+              </a:spcAft>
+            </a:pPr>
+            <a:r>
+              <a:rPr sz="900" b="0" i="0">
+                <a:solidFill>
+                  <a:srgbClr val="F5F6FA"/>
+                </a:solidFill>
+                <a:latin typeface="Consolas"/>
+              </a:rPr>
+              <a:t>..\.venv\Scripts\python 01_lead_scoring.py</a:t>
+            </a:r>
+          </a:p>
+          <a:p>
+            <a:pPr algn="l">
+              <a:lnSpc>
+                <a:spcPct val="110000"/>
+              </a:lnSpc>
+              <a:spcAft>
+                <a:spcPts val="0"/>
+              </a:spcAft>
+            </a:pPr>
+            <a:r>
+              <a:rPr sz="900" b="0" i="0">
+                <a:solidFill>
+                  <a:srgbClr val="F5F6FA"/>
+                </a:solidFill>
+                <a:latin typeface="Consolas"/>
+              </a:rPr>
+              <a:t>..\.venv\Scripts\python 07_ui_demos.py   # UI demos</a:t>
+            </a:r>
+          </a:p>
+        </p:txBody>
+      </p:sp>
+    </p:spTree>
+  </p:cSld>
+  <p:clrMapOvr>
+    <a:masterClrMapping/>
+  </p:clrMapOvr>
+</p:sld>
+</file>
+
+<file path=ppt/slides/slide5.xml><?xml version="1.0" encoding="utf-8"?>
+<p:sld xmlns:a="http://schemas.openxmlformats.org/drawingml/2006/main" xmlns:p="http://schemas.openxmlformats.org/presentationml/2006/main" xmlns:r="http://schemas.openxmlformats.org/officeDocument/2006/relationships">
+  <p:cSld>
+    <p:bg>
+      <p:bgPr>
+        <a:solidFill>
+          <a:srgbClr val="0F1117"/>
+        </a:solidFill>
+        <a:effectLst/>
+      </p:bgPr>
+    </p:bg>
+    <p:spTree>
+      <p:nvGrpSpPr>
+        <p:cNvPr id="1" name=""/>
+        <p:cNvGrpSpPr/>
+        <p:nvPr/>
+      </p:nvGrpSpPr>
+      <p:grpSpPr/>
+      <p:sp>
+        <p:nvSpPr>
+          <p:cNvPr id="2" name="TextBox 1"/>
+          <p:cNvSpPr txBox="1"/>
+          <p:nvPr/>
+        </p:nvSpPr>
+        <p:spPr>
+          <a:xfrm>
+            <a:off x="457200" y="292608"/>
+            <a:ext cx="8229600" cy="274320"/>
+          </a:xfrm>
+          <a:prstGeom prst="rect">
+            <a:avLst/>
+          </a:prstGeom>
+          <a:noFill/>
+        </p:spPr>
+        <p:txBody>
+          <a:bodyPr wrap="square" anchor="t" lIns="36576" rIns="36576" tIns="36576" bIns="36576">
+            <a:spAutoFit/>
+          </a:bodyPr>
+          <a:lstStyle/>
+          <a:p>
+            <a:pPr algn="l">
+              <a:lnSpc>
+                <a:spcPct val="100000"/>
+              </a:lnSpc>
+              <a:spcAft>
+                <a:spcPts val="0"/>
+              </a:spcAft>
+            </a:pPr>
+            <a:r>
+              <a:rPr sz="1100" b="0" i="0">
+                <a:solidFill>
+                  <a:srgbClr val="22D3EE"/>
+                </a:solidFill>
+                <a:latin typeface="Segoe UI Semibold"/>
+              </a:rPr>
+              <a:t>HANDS-ON  ·  5 / 6</a:t>
+            </a:r>
+          </a:p>
+        </p:txBody>
+      </p:sp>
+      <p:sp>
+        <p:nvSpPr>
+          <p:cNvPr id="3" name="TextBox 2"/>
+          <p:cNvSpPr txBox="1"/>
+          <p:nvPr/>
+        </p:nvSpPr>
+        <p:spPr>
+          <a:xfrm>
+            <a:off x="457200" y="530352"/>
+            <a:ext cx="11247120" cy="640080"/>
+          </a:xfrm>
+          <a:prstGeom prst="rect">
+            <a:avLst/>
+          </a:prstGeom>
+          <a:noFill/>
+        </p:spPr>
+        <p:txBody>
+          <a:bodyPr wrap="square" anchor="t" lIns="36576" rIns="36576" tIns="36576" bIns="36576">
+            <a:spAutoFit/>
+          </a:bodyPr>
+          <a:lstStyle/>
+          <a:p>
+            <a:pPr algn="l">
+              <a:lnSpc>
+                <a:spcPct val="100000"/>
+              </a:lnSpc>
+              <a:spcAft>
+                <a:spcPts val="0"/>
+              </a:spcAft>
+            </a:pPr>
+            <a:r>
+              <a:rPr sz="3000" b="0" i="0">
+                <a:solidFill>
+                  <a:srgbClr val="F5F6FA"/>
+                </a:solidFill>
+                <a:latin typeface="Segoe UI Semibold"/>
+              </a:rPr>
+              <a:t>We built it: 7 samples running locally on Laya</a:t>
+            </a:r>
+          </a:p>
+        </p:txBody>
+      </p:sp>
+      <p:sp>
+        <p:nvSpPr>
+          <p:cNvPr id="4" name="TextBox 3"/>
+          <p:cNvSpPr txBox="1"/>
+          <p:nvPr/>
+        </p:nvSpPr>
+        <p:spPr>
+          <a:xfrm>
+            <a:off x="457200" y="1115568"/>
+            <a:ext cx="7132320" cy="365760"/>
+          </a:xfrm>
+          <a:prstGeom prst="rect">
+            <a:avLst/>
+          </a:prstGeom>
+          <a:noFill/>
+        </p:spPr>
+        <p:txBody>
+          <a:bodyPr wrap="square" anchor="t" lIns="36576" rIns="36576" tIns="36576" bIns="36576">
+            <a:spAutoFit/>
+          </a:bodyPr>
+          <a:lstStyle/>
+          <a:p>
+            <a:pPr algn="l">
+              <a:lnSpc>
+                <a:spcPct val="100000"/>
+              </a:lnSpc>
+              <a:spcAft>
+                <a:spcPts val="0"/>
+              </a:spcAft>
+            </a:pPr>
+            <a:r>
+              <a:rPr sz="1400" b="0" i="0">
+                <a:solidFill>
+                  <a:srgbClr val="A3A9BC"/>
+                </a:solidFill>
+                <a:latin typeface="Segoe UI"/>
+              </a:rPr>
+              <a:t>Laya: open-source (Apache-2.0), Jev-compatible, 421M params. Runs on a laptop CPU.</a:t>
+            </a:r>
+          </a:p>
+        </p:txBody>
+      </p:sp>
+      <p:sp>
+        <p:nvSpPr>
+          <p:cNvPr id="5" name="TextBox 4">
+            <a:hlinkClick r:id="rId2"/>
+          </p:cNvPr>
+          <p:cNvSpPr txBox="1"/>
+          <p:nvPr/>
+        </p:nvSpPr>
+        <p:spPr>
+          <a:xfrm>
+            <a:off x="7726679" y="1143000"/>
+            <a:ext cx="4023360" cy="292608"/>
+          </a:xfrm>
+          <a:prstGeom prst="rect">
+            <a:avLst/>
+          </a:prstGeom>
+          <a:noFill/>
+        </p:spPr>
+        <p:txBody>
+          <a:bodyPr wrap="square" anchor="t" lIns="36576" rIns="36576" tIns="36576" bIns="36576">
+            <a:spAutoFit/>
+          </a:bodyPr>
+          <a:lstStyle/>
+          <a:p>
+            <a:pPr algn="l">
+              <a:lnSpc>
+                <a:spcPct val="100000"/>
+              </a:lnSpc>
+              <a:spcAft>
+                <a:spcPts val="0"/>
+              </a:spcAft>
+            </a:pPr>
+            <a:r>
+              <a:rPr sz="1300" b="0" i="0">
+                <a:solidFill>
+                  <a:srgbClr val="A3A9BC"/>
+                </a:solidFill>
+                <a:latin typeface="Segoe UI"/>
+              </a:rPr>
+              <a:t>Code:  </a:t>
+            </a:r>
+            <a:r>
+              <a:rPr sz="1300" b="0" i="0" u="sng">
+                <a:solidFill>
+                  <a:srgbClr val="22D3EE"/>
+                </a:solidFill>
+                <a:latin typeface="Segoe UI Semibold"/>
+              </a:rPr>
+              <a:t>github.com/stvonolf/jev-samples</a:t>
             </a:r>
           </a:p>
         </p:txBody>
       </p:sp>
       <p:graphicFrame>
         <p:nvGraphicFramePr>
-          <p:cNvPr id="5" name="Table 4"/>
+          <p:cNvPr id="6" name="Table 5"/>
           <p:cNvGraphicFramePr>
             <a:graphicFrameLocks noGrp="1"/>
           </p:cNvGraphicFramePr>
           <p:nvPr/>
         </p:nvGraphicFramePr>
         <p:xfrm>
-          <a:off x="457200" y="1645920"/>
-          <a:ext cx="7040880" cy="3200400"/>
+          <a:off x="457200" y="1600200"/>
+          <a:ext cx="7040880" cy="3218688"/>
         </p:xfrm>
         <a:graphic>
           <a:graphicData uri="http://schemas.openxmlformats.org/drawingml/2006/table">
@@ -9030,7 +11160,7 @@
                 <a:gridCol w="1554480"/>
                 <a:gridCol w="3410712"/>
               </a:tblGrid>
-              <a:tr h="457200">
+              <a:tr h="402336">
                 <a:tc>
                   <a:txBody>
                     <a:bodyPr wrap="square"/>
@@ -9216,7 +11346,7 @@
                   </a:tcPr>
                 </a:tc>
               </a:tr>
-              <a:tr h="457200">
+              <a:tr h="402336">
                 <a:tc>
                   <a:txBody>
                     <a:bodyPr wrap="square"/>
@@ -9402,7 +11532,7 @@
                   </a:tcPr>
                 </a:tc>
               </a:tr>
-              <a:tr h="457200">
+              <a:tr h="402336">
                 <a:tc>
                   <a:txBody>
                     <a:bodyPr wrap="square"/>
@@ -9588,7 +11718,7 @@
                   </a:tcPr>
                 </a:tc>
               </a:tr>
-              <a:tr h="457200">
+              <a:tr h="402336">
                 <a:tc>
                   <a:txBody>
                     <a:bodyPr wrap="square"/>
@@ -9774,7 +11904,7 @@
                   </a:tcPr>
                 </a:tc>
               </a:tr>
-              <a:tr h="457200">
+              <a:tr h="402336">
                 <a:tc>
                   <a:txBody>
                     <a:bodyPr wrap="square"/>
@@ -9960,7 +12090,7 @@
                   </a:tcPr>
                 </a:tc>
               </a:tr>
-              <a:tr h="457200">
+              <a:tr h="402336">
                 <a:tc>
                   <a:txBody>
                     <a:bodyPr wrap="square"/>
@@ -10146,7 +12276,7 @@
                   </a:tcPr>
                 </a:tc>
               </a:tr>
-              <a:tr h="457200">
+              <a:tr h="402336">
                 <a:tc>
                   <a:txBody>
                     <a:bodyPr wrap="square"/>
@@ -10332,20 +12462,206 @@
                   </a:tcPr>
                 </a:tc>
               </a:tr>
+              <a:tr h="402336">
+                <a:tc>
+                  <a:txBody>
+                    <a:bodyPr wrap="square"/>
+                    <a:lstStyle/>
+                    <a:p>
+                      <a:r>
+                        <a:rPr sz="1050" b="0" i="0">
+                          <a:solidFill>
+                            <a:srgbClr val="A3A9BC"/>
+                          </a:solidFill>
+                          <a:latin typeface="Segoe UI Semibold"/>
+                        </a:rPr>
+                        <a:t>07</a:t>
+                      </a:r>
+                    </a:p>
+                  </a:txBody>
+                  <a:tcPr marL="73152" marR="73152" marT="27432" marB="27432" anchor="ctr">
+                    <a:lnL w="9525" cap="flat" cmpd="sng" algn="ctr">
+                      <a:solidFill>
+                        <a:srgbClr val="33384A"/>
+                      </a:solidFill>
+                      <a:prstDash val="solid"/>
+                    </a:lnL>
+                    <a:lnR w="9525" cap="flat" cmpd="sng" algn="ctr">
+                      <a:solidFill>
+                        <a:srgbClr val="33384A"/>
+                      </a:solidFill>
+                      <a:prstDash val="solid"/>
+                    </a:lnR>
+                    <a:lnT w="9525" cap="flat" cmpd="sng" algn="ctr">
+                      <a:solidFill>
+                        <a:srgbClr val="33384A"/>
+                      </a:solidFill>
+                      <a:prstDash val="solid"/>
+                    </a:lnT>
+                    <a:lnB w="9525" cap="flat" cmpd="sng" algn="ctr">
+                      <a:solidFill>
+                        <a:srgbClr val="33384A"/>
+                      </a:solidFill>
+                      <a:prstDash val="solid"/>
+                    </a:lnB>
+                    <a:solidFill>
+                      <a:srgbClr val="1A1D27"/>
+                    </a:solidFill>
+                  </a:tcPr>
+                </a:tc>
+                <a:tc>
+                  <a:txBody>
+                    <a:bodyPr wrap="square"/>
+                    <a:lstStyle/>
+                    <a:p>
+                      <a:r>
+                        <a:rPr sz="1050" b="0" i="0">
+                          <a:solidFill>
+                            <a:srgbClr val="F5F6FA"/>
+                          </a:solidFill>
+                          <a:latin typeface="Segoe UI Semibold"/>
+                        </a:rPr>
+                        <a:t>UI demos (browser)</a:t>
+                      </a:r>
+                    </a:p>
+                  </a:txBody>
+                  <a:tcPr marL="73152" marR="73152" marT="27432" marB="27432" anchor="ctr">
+                    <a:lnL w="9525" cap="flat" cmpd="sng" algn="ctr">
+                      <a:solidFill>
+                        <a:srgbClr val="33384A"/>
+                      </a:solidFill>
+                      <a:prstDash val="solid"/>
+                    </a:lnL>
+                    <a:lnR w="9525" cap="flat" cmpd="sng" algn="ctr">
+                      <a:solidFill>
+                        <a:srgbClr val="33384A"/>
+                      </a:solidFill>
+                      <a:prstDash val="solid"/>
+                    </a:lnR>
+                    <a:lnT w="9525" cap="flat" cmpd="sng" algn="ctr">
+                      <a:solidFill>
+                        <a:srgbClr val="33384A"/>
+                      </a:solidFill>
+                      <a:prstDash val="solid"/>
+                    </a:lnT>
+                    <a:lnB w="9525" cap="flat" cmpd="sng" algn="ctr">
+                      <a:solidFill>
+                        <a:srgbClr val="33384A"/>
+                      </a:solidFill>
+                      <a:prstDash val="solid"/>
+                    </a:lnB>
+                    <a:solidFill>
+                      <a:srgbClr val="1A1D27"/>
+                    </a:solidFill>
+                  </a:tcPr>
+                </a:tc>
+                <a:tc>
+                  <a:txBody>
+                    <a:bodyPr wrap="square"/>
+                    <a:lstStyle/>
+                    <a:p>
+                      <a:r>
+                        <a:rPr sz="1050" b="0" i="0">
+                          <a:solidFill>
+                            <a:srgbClr val="E040FB"/>
+                          </a:solidFill>
+                          <a:latin typeface="Segoe UI Semibold"/>
+                        </a:rPr>
+                        <a:t>Choice + Score + Noul</a:t>
+                      </a:r>
+                    </a:p>
+                  </a:txBody>
+                  <a:tcPr marL="73152" marR="73152" marT="27432" marB="27432" anchor="ctr">
+                    <a:lnL w="9525" cap="flat" cmpd="sng" algn="ctr">
+                      <a:solidFill>
+                        <a:srgbClr val="33384A"/>
+                      </a:solidFill>
+                      <a:prstDash val="solid"/>
+                    </a:lnL>
+                    <a:lnR w="9525" cap="flat" cmpd="sng" algn="ctr">
+                      <a:solidFill>
+                        <a:srgbClr val="33384A"/>
+                      </a:solidFill>
+                      <a:prstDash val="solid"/>
+                    </a:lnR>
+                    <a:lnT w="9525" cap="flat" cmpd="sng" algn="ctr">
+                      <a:solidFill>
+                        <a:srgbClr val="33384A"/>
+                      </a:solidFill>
+                      <a:prstDash val="solid"/>
+                    </a:lnT>
+                    <a:lnB w="9525" cap="flat" cmpd="sng" algn="ctr">
+                      <a:solidFill>
+                        <a:srgbClr val="33384A"/>
+                      </a:solidFill>
+                      <a:prstDash val="solid"/>
+                    </a:lnB>
+                    <a:solidFill>
+                      <a:srgbClr val="1A1D27"/>
+                    </a:solidFill>
+                  </a:tcPr>
+                </a:tc>
+                <a:tc>
+                  <a:txBody>
+                    <a:bodyPr wrap="square"/>
+                    <a:lstStyle/>
+                    <a:p>
+                      <a:r>
+                        <a:rPr sz="1050" b="0" i="0">
+                          <a:solidFill>
+                            <a:srgbClr val="A3A9BC"/>
+                          </a:solidFill>
+                          <a:latin typeface="Segoe UI"/>
+                        </a:rPr>
+                        <a:t>Trolley ×100, creative emoji pile, live Score gauges for customer messages → slide 6</a:t>
+                      </a:r>
+                    </a:p>
+                  </a:txBody>
+                  <a:tcPr marL="73152" marR="73152" marT="27432" marB="27432" anchor="ctr">
+                    <a:lnL w="9525" cap="flat" cmpd="sng" algn="ctr">
+                      <a:solidFill>
+                        <a:srgbClr val="33384A"/>
+                      </a:solidFill>
+                      <a:prstDash val="solid"/>
+                    </a:lnL>
+                    <a:lnR w="9525" cap="flat" cmpd="sng" algn="ctr">
+                      <a:solidFill>
+                        <a:srgbClr val="33384A"/>
+                      </a:solidFill>
+                      <a:prstDash val="solid"/>
+                    </a:lnR>
+                    <a:lnT w="9525" cap="flat" cmpd="sng" algn="ctr">
+                      <a:solidFill>
+                        <a:srgbClr val="33384A"/>
+                      </a:solidFill>
+                      <a:prstDash val="solid"/>
+                    </a:lnT>
+                    <a:lnB w="9525" cap="flat" cmpd="sng" algn="ctr">
+                      <a:solidFill>
+                        <a:srgbClr val="33384A"/>
+                      </a:solidFill>
+                      <a:prstDash val="solid"/>
+                    </a:lnB>
+                    <a:solidFill>
+                      <a:srgbClr val="1A1D27"/>
+                    </a:solidFill>
+                  </a:tcPr>
+                </a:tc>
+              </a:tr>
             </a:tbl>
           </a:graphicData>
         </a:graphic>
       </p:graphicFrame>
       <p:pic>
         <p:nvPicPr>
-          <p:cNvPr id="6" name="Picture 5" descr="terminal_06_agent_harness.png"/>
+          <p:cNvPr id="7" name="Picture 6" descr="terminal_06_agent_harness.png"/>
           <p:cNvPicPr>
             <a:picLocks noChangeAspect="1"/>
           </p:cNvPicPr>
           <p:nvPr/>
         </p:nvPicPr>
         <p:blipFill>
-          <a:blip r:embed="rId2"/>
+          <a:blip r:embed="rId3"/>
           <a:stretch>
             <a:fillRect/>
           </a:stretch>
@@ -10367,7 +12683,7 @@
       </p:pic>
       <p:sp>
         <p:nvSpPr>
-          <p:cNvPr id="7" name="TextBox 6"/>
+          <p:cNvPr id="8" name="TextBox 7"/>
           <p:cNvSpPr txBox="1"/>
           <p:nvPr/>
         </p:nvSpPr>
@@ -10409,7 +12725,7 @@
       </p:sp>
       <p:sp>
         <p:nvSpPr>
-          <p:cNvPr id="8" name="Rounded Rectangle 7"/>
+          <p:cNvPr id="9" name="Rounded Rectangle 8"/>
           <p:cNvSpPr/>
           <p:nvPr/>
         </p:nvSpPr>
@@ -10453,7 +12769,7 @@
       </p:sp>
       <p:sp>
         <p:nvSpPr>
-          <p:cNvPr id="9" name="TextBox 8"/>
+          <p:cNvPr id="10" name="TextBox 9"/>
           <p:cNvSpPr txBox="1"/>
           <p:nvPr/>
         </p:nvSpPr>
@@ -10495,7 +12811,7 @@
       </p:sp>
       <p:sp>
         <p:nvSpPr>
-          <p:cNvPr id="10" name="TextBox 9"/>
+          <p:cNvPr id="11" name="TextBox 10"/>
           <p:cNvSpPr txBox="1"/>
           <p:nvPr/>
         </p:nvSpPr>
@@ -10666,7 +12982,7 @@
       </p:sp>
       <p:sp>
         <p:nvSpPr>
-          <p:cNvPr id="11" name="Rounded Rectangle 10"/>
+          <p:cNvPr id="12" name="Rounded Rectangle 11"/>
           <p:cNvSpPr/>
           <p:nvPr/>
         </p:nvSpPr>
@@ -10712,7 +13028,7 @@
       </p:sp>
       <p:sp>
         <p:nvSpPr>
-          <p:cNvPr id="12" name="TextBox 11"/>
+          <p:cNvPr id="13" name="TextBox 12"/>
           <p:cNvSpPr txBox="1"/>
           <p:nvPr/>
         </p:nvSpPr>
@@ -10754,7 +13070,7 @@
       </p:sp>
       <p:sp>
         <p:nvSpPr>
-          <p:cNvPr id="13" name="TextBox 12"/>
+          <p:cNvPr id="14" name="TextBox 13"/>
           <p:cNvSpPr txBox="1"/>
           <p:nvPr/>
         </p:nvSpPr>
@@ -10847,6 +13163,730 @@
                 <a:latin typeface="Segoe UI"/>
               </a:rPr>
               <a:t>4. Ship behind a confidence gate + human review</a:t>
+            </a:r>
+          </a:p>
+        </p:txBody>
+      </p:sp>
+    </p:spTree>
+  </p:cSld>
+  <p:clrMapOvr>
+    <a:masterClrMapping/>
+  </p:clrMapOvr>
+</p:sld>
+</file>
+
+<file path=ppt/slides/slide6.xml><?xml version="1.0" encoding="utf-8"?>
+<p:sld xmlns:a="http://schemas.openxmlformats.org/drawingml/2006/main" xmlns:p="http://schemas.openxmlformats.org/presentationml/2006/main" xmlns:r="http://schemas.openxmlformats.org/officeDocument/2006/relationships">
+  <p:cSld>
+    <p:bg>
+      <p:bgPr>
+        <a:solidFill>
+          <a:srgbClr val="0F1117"/>
+        </a:solidFill>
+        <a:effectLst/>
+      </p:bgPr>
+    </p:bg>
+    <p:spTree>
+      <p:nvGrpSpPr>
+        <p:cNvPr id="1" name=""/>
+        <p:cNvGrpSpPr/>
+        <p:nvPr/>
+      </p:nvGrpSpPr>
+      <p:grpSpPr/>
+      <p:sp>
+        <p:nvSpPr>
+          <p:cNvPr id="2" name="TextBox 1"/>
+          <p:cNvSpPr txBox="1"/>
+          <p:nvPr/>
+        </p:nvSpPr>
+        <p:spPr>
+          <a:xfrm>
+            <a:off x="457200" y="292608"/>
+            <a:ext cx="8229600" cy="274320"/>
+          </a:xfrm>
+          <a:prstGeom prst="rect">
+            <a:avLst/>
+          </a:prstGeom>
+          <a:noFill/>
+        </p:spPr>
+        <p:txBody>
+          <a:bodyPr wrap="square" anchor="t" lIns="36576" rIns="36576" tIns="36576" bIns="36576">
+            <a:spAutoFit/>
+          </a:bodyPr>
+          <a:lstStyle/>
+          <a:p>
+            <a:pPr algn="l">
+              <a:lnSpc>
+                <a:spcPct val="100000"/>
+              </a:lnSpc>
+              <a:spcAft>
+                <a:spcPts val="0"/>
+              </a:spcAft>
+            </a:pPr>
+            <a:r>
+              <a:rPr sz="1100" b="0" i="0">
+                <a:solidFill>
+                  <a:srgbClr val="22D3EE"/>
+                </a:solidFill>
+                <a:latin typeface="Segoe UI Semibold"/>
+              </a:rPr>
+              <a:t>LIVE DEMOS  ·  6 / 6</a:t>
+            </a:r>
+          </a:p>
+        </p:txBody>
+      </p:sp>
+      <p:sp>
+        <p:nvSpPr>
+          <p:cNvPr id="3" name="TextBox 2"/>
+          <p:cNvSpPr txBox="1"/>
+          <p:nvPr/>
+        </p:nvSpPr>
+        <p:spPr>
+          <a:xfrm>
+            <a:off x="457200" y="530352"/>
+            <a:ext cx="11247120" cy="640080"/>
+          </a:xfrm>
+          <a:prstGeom prst="rect">
+            <a:avLst/>
+          </a:prstGeom>
+          <a:noFill/>
+        </p:spPr>
+        <p:txBody>
+          <a:bodyPr wrap="square" anchor="t" lIns="36576" rIns="36576" tIns="36576" bIns="36576">
+            <a:spAutoFit/>
+          </a:bodyPr>
+          <a:lstStyle/>
+          <a:p>
+            <a:pPr algn="l">
+              <a:lnSpc>
+                <a:spcPct val="100000"/>
+              </a:lnSpc>
+              <a:spcAft>
+                <a:spcPts val="0"/>
+              </a:spcAft>
+            </a:pPr>
+            <a:r>
+              <a:rPr sz="3000" b="0" i="0">
+                <a:solidFill>
+                  <a:srgbClr val="F5F6FA"/>
+                </a:solidFill>
+                <a:latin typeface="Segoe UI Semibold"/>
+              </a:rPr>
+              <a:t>Three live UI demos: Choice, Noul and Score</a:t>
+            </a:r>
+          </a:p>
+        </p:txBody>
+      </p:sp>
+      <p:sp>
+        <p:nvSpPr>
+          <p:cNvPr id="4" name="TextBox 3">
+            <a:hlinkClick r:id="rId2"/>
+          </p:cNvPr>
+          <p:cNvSpPr txBox="1"/>
+          <p:nvPr/>
+        </p:nvSpPr>
+        <p:spPr>
+          <a:xfrm>
+            <a:off x="457200" y="1115568"/>
+            <a:ext cx="11247120" cy="292608"/>
+          </a:xfrm>
+          <a:prstGeom prst="rect">
+            <a:avLst/>
+          </a:prstGeom>
+          <a:noFill/>
+        </p:spPr>
+        <p:txBody>
+          <a:bodyPr wrap="square" anchor="t" lIns="36576" rIns="36576" tIns="36576" bIns="36576">
+            <a:spAutoFit/>
+          </a:bodyPr>
+          <a:lstStyle/>
+          <a:p>
+            <a:pPr algn="l">
+              <a:lnSpc>
+                <a:spcPct val="100000"/>
+              </a:lnSpc>
+              <a:spcAft>
+                <a:spcPts val="0"/>
+              </a:spcAft>
+            </a:pPr>
+            <a:r>
+              <a:rPr sz="1300" b="0" i="0">
+                <a:solidFill>
+                  <a:srgbClr val="A3A9BC"/>
+                </a:solidFill>
+                <a:latin typeface="Segoe UI"/>
+              </a:rPr>
+              <a:t>Run:  </a:t>
+            </a:r>
+            <a:r>
+              <a:rPr sz="1300" b="0" i="0" u="sng">
+                <a:solidFill>
+                  <a:srgbClr val="22D3EE"/>
+                </a:solidFill>
+                <a:latin typeface="Segoe UI Semibold"/>
+              </a:rPr>
+              <a:t>python samples\07_ui_demos.py  →  http://localhost:8765</a:t>
+            </a:r>
+          </a:p>
+        </p:txBody>
+      </p:sp>
+      <p:pic>
+        <p:nvPicPr>
+          <p:cNvPr id="5" name="Picture 4" descr="ui_trolley.png"/>
+          <p:cNvPicPr>
+            <a:picLocks noChangeAspect="1"/>
+          </p:cNvPicPr>
+          <p:nvPr/>
+        </p:nvPicPr>
+        <p:blipFill>
+          <a:blip r:embed="rId3"/>
+          <a:stretch>
+            <a:fillRect/>
+          </a:stretch>
+        </p:blipFill>
+        <p:spPr>
+          <a:xfrm>
+            <a:off x="457200" y="1554480"/>
+            <a:ext cx="3611880" cy="2152680"/>
+          </a:xfrm>
+          <a:prstGeom prst="rect">
+            <a:avLst/>
+          </a:prstGeom>
+          <a:ln w="12700">
+            <a:solidFill>
+              <a:srgbClr val="33384A"/>
+            </a:solidFill>
+          </a:ln>
+        </p:spPr>
+      </p:pic>
+      <p:sp>
+        <p:nvSpPr>
+          <p:cNvPr id="6" name="TextBox 5"/>
+          <p:cNvSpPr txBox="1"/>
+          <p:nvPr/>
+        </p:nvSpPr>
+        <p:spPr>
+          <a:xfrm>
+            <a:off x="457200" y="3992757"/>
+            <a:ext cx="3611880" cy="320040"/>
+          </a:xfrm>
+          <a:prstGeom prst="rect">
+            <a:avLst/>
+          </a:prstGeom>
+          <a:noFill/>
+        </p:spPr>
+        <p:txBody>
+          <a:bodyPr wrap="square" anchor="t" lIns="36576" rIns="36576" tIns="36576" bIns="36576">
+            <a:spAutoFit/>
+          </a:bodyPr>
+          <a:lstStyle/>
+          <a:p>
+            <a:pPr algn="l">
+              <a:lnSpc>
+                <a:spcPct val="100000"/>
+              </a:lnSpc>
+              <a:spcAft>
+                <a:spcPts val="0"/>
+              </a:spcAft>
+            </a:pPr>
+            <a:r>
+              <a:rPr sz="1300" b="0" i="0">
+                <a:solidFill>
+                  <a:srgbClr val="F5F6FA"/>
+                </a:solidFill>
+                <a:latin typeface="Segoe UI Semibold"/>
+              </a:rPr>
+              <a:t>Trolley problem ×100</a:t>
+            </a:r>
+            <a:r>
+              <a:rPr sz="1300" b="0" i="0">
+                <a:solidFill>
+                  <a:srgbClr val="E040FB"/>
+                </a:solidFill>
+                <a:latin typeface="Segoe UI Semibold"/>
+              </a:rPr>
+              <a:t>   Choice</a:t>
+            </a:r>
+          </a:p>
+        </p:txBody>
+      </p:sp>
+      <p:sp>
+        <p:nvSpPr>
+          <p:cNvPr id="7" name="TextBox 6"/>
+          <p:cNvSpPr txBox="1"/>
+          <p:nvPr/>
+        </p:nvSpPr>
+        <p:spPr>
+          <a:xfrm>
+            <a:off x="457200" y="4340229"/>
+            <a:ext cx="3611880" cy="2103120"/>
+          </a:xfrm>
+          <a:prstGeom prst="rect">
+            <a:avLst/>
+          </a:prstGeom>
+          <a:noFill/>
+        </p:spPr>
+        <p:txBody>
+          <a:bodyPr wrap="square" anchor="t" lIns="36576" rIns="36576" tIns="36576" bIns="36576">
+            <a:spAutoFit/>
+          </a:bodyPr>
+          <a:lstStyle/>
+          <a:p>
+            <a:pPr algn="l">
+              <a:lnSpc>
+                <a:spcPct val="100000"/>
+              </a:lnSpc>
+              <a:spcAft>
+                <a:spcPts val="400"/>
+              </a:spcAft>
+            </a:pPr>
+            <a:r>
+              <a:rPr sz="1050" b="0" i="0">
+                <a:solidFill>
+                  <a:srgbClr val="E040FB"/>
+                </a:solidFill>
+                <a:latin typeface="Segoe UI"/>
+              </a:rPr>
+              <a:t>•  </a:t>
+            </a:r>
+            <a:r>
+              <a:rPr sz="1050" b="0" i="0">
+                <a:solidFill>
+                  <a:srgbClr val="A3A9BC"/>
+                </a:solidFill>
+                <a:latin typeface="Segoe UI"/>
+              </a:rPr>
+              <a:t>Rebuilt from the video. 100 trials, randomised wording: pulled the lever 100 / 100 (P 0.75–0.98).</a:t>
+            </a:r>
+          </a:p>
+          <a:p>
+            <a:pPr algn="l">
+              <a:lnSpc>
+                <a:spcPct val="100000"/>
+              </a:lnSpc>
+              <a:spcAft>
+                <a:spcPts val="400"/>
+              </a:spcAft>
+            </a:pPr>
+            <a:r>
+              <a:rPr sz="1050" b="0" i="0">
+                <a:solidFill>
+                  <a:srgbClr val="E040FB"/>
+                </a:solidFill>
+                <a:latin typeface="Segoe UI"/>
+              </a:rPr>
+              <a:t>•  </a:t>
+            </a:r>
+            <a:r>
+              <a:rPr sz="1050" b="0" i="0">
+                <a:solidFill>
+                  <a:srgbClr val="A3A9BC"/>
+                </a:solidFill>
+                <a:latin typeface="Segoe UI"/>
+              </a:rPr>
+              <a:t>Sanity check with 1 on main and 5 on side: it still pulls (0 / 13 chose fewer deaths).</a:t>
+            </a:r>
+          </a:p>
+          <a:p>
+            <a:pPr algn="l">
+              <a:lnSpc>
+                <a:spcPct val="100000"/>
+              </a:lnSpc>
+              <a:spcAft>
+                <a:spcPts val="400"/>
+              </a:spcAft>
+            </a:pPr>
+            <a:r>
+              <a:rPr sz="1050" b="0" i="0">
+                <a:solidFill>
+                  <a:srgbClr val="E040FB"/>
+                </a:solidFill>
+                <a:latin typeface="Segoe UI"/>
+              </a:rPr>
+              <a:t>•  </a:t>
+            </a:r>
+            <a:r>
+              <a:rPr sz="1050" b="0" i="0">
+                <a:solidFill>
+                  <a:srgbClr val="A3A9BC"/>
+                </a:solidFill>
+                <a:latin typeface="Segoe UI"/>
+              </a:rPr>
+              <a:t>System-1 models react to the story pattern; they don't count.</a:t>
+            </a:r>
+          </a:p>
+        </p:txBody>
+      </p:sp>
+      <p:pic>
+        <p:nvPicPr>
+          <p:cNvPr id="8" name="Picture 7" descr="ui_creative.png"/>
+          <p:cNvPicPr>
+            <a:picLocks noChangeAspect="1"/>
+          </p:cNvPicPr>
+          <p:nvPr/>
+        </p:nvPicPr>
+        <p:blipFill>
+          <a:blip r:embed="rId4"/>
+          <a:stretch>
+            <a:fillRect/>
+          </a:stretch>
+        </p:blipFill>
+        <p:spPr>
+          <a:xfrm>
+            <a:off x="4288536" y="1554480"/>
+            <a:ext cx="3611880" cy="2124635"/>
+          </a:xfrm>
+          <a:prstGeom prst="rect">
+            <a:avLst/>
+          </a:prstGeom>
+          <a:ln w="12700">
+            <a:solidFill>
+              <a:srgbClr val="33384A"/>
+            </a:solidFill>
+          </a:ln>
+        </p:spPr>
+      </p:pic>
+      <p:sp>
+        <p:nvSpPr>
+          <p:cNvPr id="9" name="TextBox 8"/>
+          <p:cNvSpPr txBox="1"/>
+          <p:nvPr/>
+        </p:nvSpPr>
+        <p:spPr>
+          <a:xfrm>
+            <a:off x="4288536" y="3992757"/>
+            <a:ext cx="3611880" cy="320040"/>
+          </a:xfrm>
+          <a:prstGeom prst="rect">
+            <a:avLst/>
+          </a:prstGeom>
+          <a:noFill/>
+        </p:spPr>
+        <p:txBody>
+          <a:bodyPr wrap="square" anchor="t" lIns="36576" rIns="36576" tIns="36576" bIns="36576">
+            <a:spAutoFit/>
+          </a:bodyPr>
+          <a:lstStyle/>
+          <a:p>
+            <a:pPr algn="l">
+              <a:lnSpc>
+                <a:spcPct val="100000"/>
+              </a:lnSpc>
+              <a:spcAft>
+                <a:spcPts val="0"/>
+              </a:spcAft>
+            </a:pPr>
+            <a:r>
+              <a:rPr sz="1300" b="0" i="0">
+                <a:solidFill>
+                  <a:srgbClr val="F5F6FA"/>
+                </a:solidFill>
+                <a:latin typeface="Segoe UI Semibold"/>
+              </a:rPr>
+              <a:t>Creative emoji pile</a:t>
+            </a:r>
+            <a:r>
+              <a:rPr sz="1300" b="0" i="0">
+                <a:solidFill>
+                  <a:srgbClr val="FBBF24"/>
+                </a:solidFill>
+                <a:latin typeface="Segoe UI Semibold"/>
+              </a:rPr>
+              <a:t>   Noul × 235</a:t>
+            </a:r>
+          </a:p>
+        </p:txBody>
+      </p:sp>
+      <p:sp>
+        <p:nvSpPr>
+          <p:cNvPr id="10" name="TextBox 9"/>
+          <p:cNvSpPr txBox="1"/>
+          <p:nvPr/>
+        </p:nvSpPr>
+        <p:spPr>
+          <a:xfrm>
+            <a:off x="4288536" y="4340229"/>
+            <a:ext cx="3611880" cy="2103120"/>
+          </a:xfrm>
+          <a:prstGeom prst="rect">
+            <a:avLst/>
+          </a:prstGeom>
+          <a:noFill/>
+        </p:spPr>
+        <p:txBody>
+          <a:bodyPr wrap="square" anchor="t" lIns="36576" rIns="36576" tIns="36576" bIns="36576">
+            <a:spAutoFit/>
+          </a:bodyPr>
+          <a:lstStyle/>
+          <a:p>
+            <a:pPr algn="l">
+              <a:lnSpc>
+                <a:spcPct val="100000"/>
+              </a:lnSpc>
+              <a:spcAft>
+                <a:spcPts val="400"/>
+              </a:spcAft>
+            </a:pPr>
+            <a:r>
+              <a:rPr sz="1050" b="0" i="0">
+                <a:solidFill>
+                  <a:srgbClr val="FBBF24"/>
+                </a:solidFill>
+                <a:latin typeface="Segoe UI"/>
+              </a:rPr>
+              <a:t>•  </a:t>
+            </a:r>
+            <a:r>
+              <a:rPr sz="1050" b="0" i="0">
+                <a:solidFill>
+                  <a:srgbClr val="A3A9BC"/>
+                </a:solidFill>
+                <a:latin typeface="Segoe UI"/>
+              </a:rPr>
+              <a:t>Rebuilt from the video. Each emoji is one Noul: “Is this related to: &lt;request&gt;?”; outliers fly up live.</a:t>
+            </a:r>
+          </a:p>
+          <a:p>
+            <a:pPr algn="l">
+              <a:lnSpc>
+                <a:spcPct val="100000"/>
+              </a:lnSpc>
+              <a:spcAft>
+                <a:spcPts val="400"/>
+              </a:spcAft>
+            </a:pPr>
+            <a:r>
+              <a:rPr sz="1050" b="0" i="0">
+                <a:solidFill>
+                  <a:srgbClr val="FBBF24"/>
+                </a:solidFill>
+                <a:latin typeface="Segoe UI"/>
+              </a:rPr>
+              <a:t>•  </a:t>
+            </a:r>
+            <a:r>
+              <a:rPr sz="1050" b="0" i="0">
+                <a:solidFill>
+                  <a:srgbClr val="A3A9BC"/>
+                </a:solidFill>
+                <a:latin typeface="Segoe UI"/>
+              </a:rPr>
+              <a:t>Good ranking (winter → scarf, coat, gloves, socks); probability levels differ per prompt → relative threshold.</a:t>
+            </a:r>
+          </a:p>
+          <a:p>
+            <a:pPr algn="l">
+              <a:lnSpc>
+                <a:spcPct val="100000"/>
+              </a:lnSpc>
+              <a:spcAft>
+                <a:spcPts val="400"/>
+              </a:spcAft>
+            </a:pPr>
+            <a:r>
+              <a:rPr sz="1050" b="0" i="0">
+                <a:solidFill>
+                  <a:srgbClr val="FBBF24"/>
+                </a:solidFill>
+                <a:latin typeface="Segoe UI"/>
+              </a:rPr>
+              <a:t>•  </a:t>
+            </a:r>
+            <a:r>
+              <a:rPr sz="1050" b="0" i="0">
+                <a:solidFill>
+                  <a:srgbClr val="A3A9BC"/>
+                </a:solidFill>
+                <a:latin typeface="Segoe UI"/>
+              </a:rPr>
+              <a:t>“starting a band” also picks the bandage.</a:t>
+            </a:r>
+          </a:p>
+        </p:txBody>
+      </p:sp>
+      <p:pic>
+        <p:nvPicPr>
+          <p:cNvPr id="11" name="Picture 10" descr="ui_score.png"/>
+          <p:cNvPicPr>
+            <a:picLocks noChangeAspect="1"/>
+          </p:cNvPicPr>
+          <p:nvPr/>
+        </p:nvPicPr>
+        <p:blipFill>
+          <a:blip r:embed="rId5"/>
+          <a:stretch>
+            <a:fillRect/>
+          </a:stretch>
+        </p:blipFill>
+        <p:spPr>
+          <a:xfrm>
+            <a:off x="8119872" y="1554480"/>
+            <a:ext cx="3611880" cy="2301117"/>
+          </a:xfrm>
+          <a:prstGeom prst="rect">
+            <a:avLst/>
+          </a:prstGeom>
+          <a:ln w="12700">
+            <a:solidFill>
+              <a:srgbClr val="33384A"/>
+            </a:solidFill>
+          </a:ln>
+        </p:spPr>
+      </p:pic>
+      <p:sp>
+        <p:nvSpPr>
+          <p:cNvPr id="12" name="TextBox 11"/>
+          <p:cNvSpPr txBox="1"/>
+          <p:nvPr/>
+        </p:nvSpPr>
+        <p:spPr>
+          <a:xfrm>
+            <a:off x="8119872" y="3992757"/>
+            <a:ext cx="3611880" cy="320040"/>
+          </a:xfrm>
+          <a:prstGeom prst="rect">
+            <a:avLst/>
+          </a:prstGeom>
+          <a:noFill/>
+        </p:spPr>
+        <p:txBody>
+          <a:bodyPr wrap="square" anchor="t" lIns="36576" rIns="36576" tIns="36576" bIns="36576">
+            <a:spAutoFit/>
+          </a:bodyPr>
+          <a:lstStyle/>
+          <a:p>
+            <a:pPr algn="l">
+              <a:lnSpc>
+                <a:spcPct val="100000"/>
+              </a:lnSpc>
+              <a:spcAft>
+                <a:spcPts val="0"/>
+              </a:spcAft>
+            </a:pPr>
+            <a:r>
+              <a:rPr sz="1300" b="0" i="0">
+                <a:solidFill>
+                  <a:srgbClr val="F5F6FA"/>
+                </a:solidFill>
+                <a:latin typeface="Segoe UI Semibold"/>
+              </a:rPr>
+              <a:t>How hot is this message?</a:t>
+            </a:r>
+            <a:r>
+              <a:rPr sz="1300" b="0" i="0">
+                <a:solidFill>
+                  <a:srgbClr val="22D3EE"/>
+                </a:solidFill>
+                <a:latin typeface="Segoe UI Semibold"/>
+              </a:rPr>
+              <a:t>   Score × 4</a:t>
+            </a:r>
+          </a:p>
+        </p:txBody>
+      </p:sp>
+      <p:sp>
+        <p:nvSpPr>
+          <p:cNvPr id="13" name="TextBox 12"/>
+          <p:cNvSpPr txBox="1"/>
+          <p:nvPr/>
+        </p:nvSpPr>
+        <p:spPr>
+          <a:xfrm>
+            <a:off x="8119872" y="4340229"/>
+            <a:ext cx="3611880" cy="2103120"/>
+          </a:xfrm>
+          <a:prstGeom prst="rect">
+            <a:avLst/>
+          </a:prstGeom>
+          <a:noFill/>
+        </p:spPr>
+        <p:txBody>
+          <a:bodyPr wrap="square" anchor="t" lIns="36576" rIns="36576" tIns="36576" bIns="36576">
+            <a:spAutoFit/>
+          </a:bodyPr>
+          <a:lstStyle/>
+          <a:p>
+            <a:pPr algn="l">
+              <a:lnSpc>
+                <a:spcPct val="100000"/>
+              </a:lnSpc>
+              <a:spcAft>
+                <a:spcPts val="400"/>
+              </a:spcAft>
+            </a:pPr>
+            <a:r>
+              <a:rPr sz="1050" b="0" i="0">
+                <a:solidFill>
+                  <a:srgbClr val="22D3EE"/>
+                </a:solidFill>
+                <a:latin typeface="Segoe UI"/>
+              </a:rPr>
+              <a:t>•  </a:t>
+            </a:r>
+            <a:r>
+              <a:rPr sz="1050" b="0" i="0">
+                <a:solidFill>
+                  <a:srgbClr val="A3A9BC"/>
+                </a:solidFill>
+                <a:latin typeface="Segoe UI"/>
+              </a:rPr>
+              <a:t>Frustration, urgency, churn risk and sentiment, re-scored while you type.</a:t>
+            </a:r>
+          </a:p>
+          <a:p>
+            <a:pPr algn="l">
+              <a:lnSpc>
+                <a:spcPct val="100000"/>
+              </a:lnSpc>
+              <a:spcAft>
+                <a:spcPts val="400"/>
+              </a:spcAft>
+            </a:pPr>
+            <a:r>
+              <a:rPr sz="1050" b="0" i="0">
+                <a:solidFill>
+                  <a:srgbClr val="22D3EE"/>
+                </a:solidFill>
+                <a:latin typeface="Segoe UI"/>
+              </a:rPr>
+              <a:t>•  </a:t>
+            </a:r>
+            <a:r>
+              <a:rPr sz="1050" b="0" i="0">
+                <a:solidFill>
+                  <a:srgbClr val="A3A9BC"/>
+                </a:solidFill>
+                <a:latin typeface="Segoe UI"/>
+              </a:rPr>
+              <a:t>Answers land between levels: frustration 0.96 → 1.42 → 1.84 → 2.11 → 2.44 as the message escalates.</a:t>
+            </a:r>
+          </a:p>
+          <a:p>
+            <a:pPr algn="l">
+              <a:lnSpc>
+                <a:spcPct val="100000"/>
+              </a:lnSpc>
+              <a:spcAft>
+                <a:spcPts val="400"/>
+              </a:spcAft>
+            </a:pPr>
+            <a:r>
+              <a:rPr sz="1050" b="0" i="0">
+                <a:solidFill>
+                  <a:srgbClr val="22D3EE"/>
+                </a:solidFill>
+                <a:latin typeface="Segoe UI"/>
+              </a:rPr>
+              <a:t>•  </a:t>
+            </a:r>
+            <a:r>
+              <a:rPr sz="1050" b="0" i="0">
+                <a:solidFill>
+                  <a:srgbClr val="A3A9BC"/>
+                </a:solidFill>
+                <a:latin typeface="Segoe UI"/>
+              </a:rPr>
+              <a:t>Code: priority 0.81 → escalate to retention; a thank-you note → testimonial for marketing.</a:t>
             </a:r>
           </a:p>
         </p:txBody>

</xml_diff>

<commit_message>
Add TypeSafe homepage and System One details to the deck
- Slide 1: TypeSafe positioning ('opposite research direction - not chat'), RLHF issues, new architecture/sampler/RLCD, homepage speed/cost claims, text-only input
- Slide 2: good-to-know line (text input only, calibration across many predictions) + System One refund workflow in notes
- Slide 3: limits clarify 'zero hallucinations'; slide 4: console.typesafe.ai sign-in
- README: add typesafe.ai and System One sources

Co-authored-by: Copilot App <223556219+Copilot@users.noreply.github.com>
</commit_message>
<xml_diff>
--- a/presentation/Jev_Team_Overview.pptx
+++ b/presentation/Jev_Team_Overview.pptx
@@ -513,13 +513,25 @@
           <a:p/>
           <a:p>
             <a:r>
+              <a:t>TYPESAFE'S OWN POSITIONING (typesafe.ai): "an AI lab building machine-native intelligence infrastructure for automation". "We took the opposite research direction - not chat": RLHF optimises for human preference and produces superhuman instruction followers, but also mode dropping, overconfidence and a lack of reliability, so LLMs need humans in the loop. System One models are built to be used natively by machines, with a new architecture, a new sampler and a new training algorithm (RLCD). Taglines: "Decisions, not strings", "calibrated confidence", "more like code: reliable, fast, type-safe". Headline claim: 193.6x faster and 444.6x cheaper on workflows for System One tasks (their demo: $0.000081 in 0.114 s vs an LLM at $0.013880 in 8.566 s); $42 per billion input tokens (= $0.042 per million), "238x lower input price than Claude Fable 5.1". They also claim "zero hallucinations" - read that as "always a valid typed answer", not "always right". All vendor-reported.</a:t>
+            </a:r>
+          </a:p>
+          <a:p/>
+          <a:p>
+            <a:r>
+              <a:t>SYSTEM ONE (docs.typesafe.ai/concepts/system-one): text input only (strings, JSON objects, arrays of text) - images, audio and video are not supported yet. Calibration is measured across groups of predictions; it does not guarantee that a single answer is correct. No replies, no code, no explanations of reasoning.</a:t>
+            </a:r>
+          </a:p>
+          <a:p/>
+          <a:p>
+            <a:r>
               <a:t>WHY (Caleb Writes Code, "Jev explained in 7min"): the AI stack's application layer pushed models toward chat (RLHF) and coding agents (RLVR). Workflow automation never crossed the cost/speed threshold, even with very capable models. TypeSafe argues that forcing chat/agent-optimised models into automation is the wrong approach and trains for calibrated decisions instead (RLCD). Most community demos show off speed (sorting email, RAG, games, model routing) rather than depth - LLMs can do these functionally, but not at 70-500 ms, because they generate tokens one after another.</a:t>
             </a:r>
           </a:p>
           <a:p/>
           <a:p>
             <a:r>
-              <a:t>HOW FAST/CHEAP: vendor-reported 40-200x faster; LangChain quotes 20-200x faster and 40-400x cheaper on classification-style tasks. Price $0.042 per 1M input tokens, output free (~$0.0004 per decision).</a:t>
+              <a:t>HOW FAST/CHEAP: video 1 quotes 40-200x faster at 70-500 ms end-to-end; LangChain quotes 20-200x faster and 40-400x cheaper on classification-style tasks; TypeSafe's homepage says 193.6x faster / 444.6x cheaper on System One workflows. Price $0.042 per 1M input tokens, output free (~$0.0004 per decision).</a:t>
             </a:r>
           </a:p>
           <a:p/>
@@ -645,6 +657,12 @@
           <a:p>
             <a:r>
               <a:t>DOCS PATTERNS: confidence-gated routing (the answer tells you WHAT, confidence tells you WHETHER to act), composite scoring (atomic scores, weights in code), speculative fan-out (ask everything in one call, code decides what is relevant), intent routing.</a:t>
+            </a:r>
+          </a:p>
+          <a:p/>
+          <a:p>
+            <a:r>
+              <a:t>SYSTEM ONE WORKFLOW (docs.typesafe.ai/concepts/system-one) - refund request: 1) build a state with the customer's message, the relevant transactions and the refund policy; 2) ask independent questions together (refund requested? evidence of a duplicate charge? does the policy support a refund?); 3) combine the answers with deterministic checks in code and route the case for action or review. Confidence decides when to act and when to escalate to a person or a reasoning model. Inputs are text only (strings, JSON objects, arrays of text); calibration holds across groups of predictions, not for every single answer.</a:t>
             </a:r>
           </a:p>
           <a:p/>
@@ -4248,7 +4266,25 @@
                 </a:solidFill>
                 <a:latin typeface="Segoe UI"/>
               </a:rPr>
-              <a:t>TypeSafe AI's first “System One” model: fast, typed, calibrated decisions that software can use directly.</a:t>
+              <a:t>TypeSafe AI: </a:t>
+            </a:r>
+            <a:r>
+              <a:rPr sz="1400" b="0" i="1">
+                <a:solidFill>
+                  <a:srgbClr val="F5F6FA"/>
+                </a:solidFill>
+                <a:latin typeface="Segoe UI"/>
+              </a:rPr>
+              <a:t>“We took the opposite research direction - not chat.” </a:t>
+            </a:r>
+            <a:r>
+              <a:rPr sz="1400" b="0" i="0">
+                <a:solidFill>
+                  <a:srgbClr val="A3A9BC"/>
+                </a:solidFill>
+                <a:latin typeface="Segoe UI"/>
+              </a:rPr>
+              <a:t>Its first System One model makes typed, calibrated decisions for software.</a:t>
             </a:r>
           </a:p>
         </p:txBody>
@@ -4262,7 +4298,7 @@
         <p:spPr>
           <a:xfrm>
             <a:off x="457200" y="2514600"/>
-            <a:ext cx="6720840" cy="4023360"/>
+            <a:ext cx="6720840" cy="3749039"/>
           </a:xfrm>
           <a:prstGeom prst="rect">
             <a:avLst/>
@@ -4280,11 +4316,11 @@
                 <a:spcPct val="105000"/>
               </a:lnSpc>
               <a:spcAft>
-                <a:spcPts val="1100"/>
+                <a:spcPts val="800"/>
               </a:spcAft>
             </a:pPr>
             <a:r>
-              <a:rPr sz="1400" b="0" i="0">
+              <a:rPr sz="1300" b="0" i="0">
                 <a:solidFill>
                   <a:srgbClr val="22D3EE"/>
                 </a:solidFill>
@@ -4293,7 +4329,7 @@
               <a:t>▸  </a:t>
             </a:r>
             <a:r>
-              <a:rPr sz="1400" b="0" i="0">
+              <a:rPr sz="1300" b="0" i="0">
                 <a:solidFill>
                   <a:srgbClr val="F5F6FA"/>
                 </a:solidFill>
@@ -4302,13 +4338,13 @@
               <a:t>What it is.  </a:t>
             </a:r>
             <a:r>
-              <a:rPr sz="1400" b="0" i="0">
+              <a:rPr sz="1300" b="0" i="0">
                 <a:solidFill>
                   <a:srgbClr val="A3A9BC"/>
                 </a:solidFill>
                 <a:latin typeface="Segoe UI"/>
               </a:rPr>
-              <a:t>Input = a state (text or JSON) + typed questions. Output = typed answers with calibrated probabilities. It never generates text, so there is nothing to parse and no broken schema.</a:t>
+              <a:t>Input = a state (text, JSON or arrays of text; no images or audio yet) + typed questions. Output = typed answers with calibrated probabilities. No text generation: nothing to parse, no broken schema.</a:t>
             </a:r>
           </a:p>
           <a:p>
@@ -4317,11 +4353,11 @@
                 <a:spcPct val="105000"/>
               </a:lnSpc>
               <a:spcAft>
-                <a:spcPts val="1100"/>
+                <a:spcPts val="800"/>
               </a:spcAft>
             </a:pPr>
             <a:r>
-              <a:rPr sz="1400" b="0" i="0">
+              <a:rPr sz="1300" b="0" i="0">
                 <a:solidFill>
                   <a:srgbClr val="22D3EE"/>
                 </a:solidFill>
@@ -4330,7 +4366,7 @@
               <a:t>▸  </a:t>
             </a:r>
             <a:r>
-              <a:rPr sz="1400" b="0" i="0">
+              <a:rPr sz="1300" b="0" i="0">
                 <a:solidFill>
                   <a:srgbClr val="F5F6FA"/>
                 </a:solidFill>
@@ -4339,13 +4375,13 @@
               <a:t>Why it exists.  </a:t>
             </a:r>
             <a:r>
-              <a:rPr sz="1400" b="0" i="0">
+              <a:rPr sz="1300" b="0" i="0">
                 <a:solidFill>
                   <a:srgbClr val="A3A9BC"/>
                 </a:solidFill>
                 <a:latin typeface="Segoe UI"/>
               </a:rPr>
-              <a:t>LLMs were optimised for chat (RLHF) and coding agents (RLVR). Workflow automation needs thousands of quick decisions under uncertainty: the neglected use case.</a:t>
+              <a:t>RLHF made LLMs great at chat, but brings mode dropping, overconfidence and unreliability - so they need a human in the loop. Automation needs thousands of reliable decisions.</a:t>
             </a:r>
           </a:p>
           <a:p>
@@ -4354,11 +4390,11 @@
                 <a:spcPct val="105000"/>
               </a:lnSpc>
               <a:spcAft>
-                <a:spcPts val="1100"/>
+                <a:spcPts val="800"/>
               </a:spcAft>
             </a:pPr>
             <a:r>
-              <a:rPr sz="1400" b="0" i="0">
+              <a:rPr sz="1300" b="0" i="0">
                 <a:solidFill>
                   <a:srgbClr val="22D3EE"/>
                 </a:solidFill>
@@ -4367,22 +4403,22 @@
               <a:t>▸  </a:t>
             </a:r>
             <a:r>
-              <a:rPr sz="1400" b="0" i="0">
+              <a:rPr sz="1300" b="0" i="0">
                 <a:solidFill>
                   <a:srgbClr val="F5F6FA"/>
                 </a:solidFill>
                 <a:latin typeface="Segoe UI Semibold"/>
               </a:rPr>
-              <a:t>How it is trained.  </a:t>
-            </a:r>
-            <a:r>
-              <a:rPr sz="1400" b="0" i="0">
+              <a:t>How it is built.  </a:t>
+            </a:r>
+            <a:r>
+              <a:rPr sz="1300" b="0" i="0">
                 <a:solidFill>
                   <a:srgbClr val="A3A9BC"/>
                 </a:solidFill>
                 <a:latin typeface="Segoe UI"/>
               </a:rPr>
-              <a:t>RLCD = reinforcement learning for calibrated decisions. Rewards come from proper scoring rules, so honest probabilities score best.</a:t>
+              <a:t>New architecture, new sampler and a new training algorithm: RLCD (reinforcement learning for calibrated decisions) - honest probabilities score best.</a:t>
             </a:r>
           </a:p>
           <a:p>
@@ -4391,11 +4427,11 @@
                 <a:spcPct val="105000"/>
               </a:lnSpc>
               <a:spcAft>
-                <a:spcPts val="1100"/>
+                <a:spcPts val="800"/>
               </a:spcAft>
             </a:pPr>
             <a:r>
-              <a:rPr sz="1400" b="0" i="0">
+              <a:rPr sz="1300" b="0" i="0">
                 <a:solidFill>
                   <a:srgbClr val="22D3EE"/>
                 </a:solidFill>
@@ -4404,7 +4440,7 @@
               <a:t>▸  </a:t>
             </a:r>
             <a:r>
-              <a:rPr sz="1400" b="0" i="0">
+              <a:rPr sz="1300" b="0" i="0">
                 <a:solidFill>
                   <a:srgbClr val="F5F6FA"/>
                 </a:solidFill>
@@ -4413,13 +4449,13 @@
               <a:t>Speed and cost.  </a:t>
             </a:r>
             <a:r>
-              <a:rPr sz="1400" b="0" i="0">
+              <a:rPr sz="1300" b="0" i="0">
                 <a:solidFill>
                   <a:srgbClr val="A3A9BC"/>
                 </a:solidFill>
                 <a:latin typeface="Segoe UI"/>
               </a:rPr>
-              <a:t>All questions in one parallel pass: 70–500 ms, 20–200× faster and 40–400× cheaper than LLMs on classification-style tasks. $0.042 per 1M input tokens, output is free.</a:t>
+              <a:t>All questions in one parallel pass. TypeSafe: 193.6× faster, 444.6× cheaper on System One workflows (0.11 s / $0.00008 vs 8.6 s / $0.014); $42 per billion input tokens, output free.</a:t>
             </a:r>
           </a:p>
           <a:p>
@@ -4428,11 +4464,11 @@
                 <a:spcPct val="105000"/>
               </a:lnSpc>
               <a:spcAft>
-                <a:spcPts val="1100"/>
+                <a:spcPts val="800"/>
               </a:spcAft>
             </a:pPr>
             <a:r>
-              <a:rPr sz="1400" b="0" i="0">
+              <a:rPr sz="1300" b="0" i="0">
                 <a:solidFill>
                   <a:srgbClr val="22D3EE"/>
                 </a:solidFill>
@@ -4441,7 +4477,7 @@
               <a:t>▸  </a:t>
             </a:r>
             <a:r>
-              <a:rPr sz="1400" b="0" i="0">
+              <a:rPr sz="1300" b="0" i="0">
                 <a:solidFill>
                   <a:srgbClr val="F5F6FA"/>
                 </a:solidFill>
@@ -4450,7 +4486,7 @@
               <a:t>Not an LLM replacement.  </a:t>
             </a:r>
             <a:r>
-              <a:rPr sz="1400" b="0" i="0">
+              <a:rPr sz="1300" b="0" i="0">
                 <a:solidFill>
                   <a:srgbClr val="A3A9BC"/>
                 </a:solidFill>
@@ -6728,7 +6764,58 @@
       </p:sp>
       <p:sp>
         <p:nvSpPr>
-          <p:cNvPr id="26" name="Rounded Rectangle 25"/>
+          <p:cNvPr id="26" name="TextBox 25"/>
+          <p:cNvSpPr txBox="1"/>
+          <p:nvPr/>
+        </p:nvSpPr>
+        <p:spPr>
+          <a:xfrm>
+            <a:off x="621792" y="5989320"/>
+            <a:ext cx="5394960" cy="411480"/>
+          </a:xfrm>
+          <a:prstGeom prst="rect">
+            <a:avLst/>
+          </a:prstGeom>
+          <a:noFill/>
+        </p:spPr>
+        <p:txBody>
+          <a:bodyPr wrap="square" anchor="t" lIns="36576" rIns="36576" tIns="36576" bIns="36576">
+            <a:spAutoFit/>
+          </a:bodyPr>
+          <a:lstStyle/>
+          <a:p>
+            <a:pPr algn="l">
+              <a:lnSpc>
+                <a:spcPct val="100000"/>
+              </a:lnSpc>
+              <a:spcAft>
+                <a:spcPts val="0"/>
+              </a:spcAft>
+            </a:pPr>
+            <a:r>
+              <a:rPr sz="1000" b="0" i="0">
+                <a:solidFill>
+                  <a:srgbClr val="F5F6FA"/>
+                </a:solidFill>
+                <a:latin typeface="Segoe UI Semibold"/>
+              </a:rPr>
+              <a:t>Good to know: </a:t>
+            </a:r>
+            <a:r>
+              <a:rPr sz="1000" b="0" i="0">
+                <a:solidFill>
+                  <a:srgbClr val="A3A9BC"/>
+                </a:solidFill>
+                <a:latin typeface="Segoe UI"/>
+              </a:rPr>
+              <a:t>text input only (strings, JSON, arrays) · calibration holds across many predictions, not for every single answer</a:t>
+            </a:r>
+          </a:p>
+        </p:txBody>
+      </p:sp>
+      <p:sp>
+        <p:nvSpPr>
+          <p:cNvPr id="27" name="Rounded Rectangle 26"/>
           <p:cNvSpPr/>
           <p:nvPr/>
         </p:nvSpPr>
@@ -6772,7 +6859,7 @@
       </p:sp>
       <p:sp>
         <p:nvSpPr>
-          <p:cNvPr id="27" name="TextBox 26"/>
+          <p:cNvPr id="28" name="TextBox 27"/>
           <p:cNvSpPr txBox="1"/>
           <p:nvPr/>
         </p:nvSpPr>
@@ -6823,7 +6910,7 @@
       </p:sp>
       <p:sp>
         <p:nvSpPr>
-          <p:cNvPr id="28" name="TextBox 27"/>
+          <p:cNvPr id="29" name="TextBox 28"/>
           <p:cNvSpPr txBox="1"/>
           <p:nvPr/>
         </p:nvSpPr>
@@ -6957,7 +7044,7 @@
       </p:sp>
       <p:sp>
         <p:nvSpPr>
-          <p:cNvPr id="29" name="TextBox 28">
+          <p:cNvPr id="30" name="TextBox 29">
             <a:hlinkClick r:id="rId2"/>
           </p:cNvPr>
           <p:cNvSpPr txBox="1"/>
@@ -9149,7 +9236,7 @@
                 </a:solidFill>
                 <a:latin typeface="Segoe UI"/>
               </a:rPr>
-              <a:t>no rationale (a number, not a reason) · closed answer sets only · triage-grade accuracy (vendor benchmark ~68% vs ~73% for frontier LLMs) · early access, price may change. If the answer must be written, it belongs to an LLM.</a:t>
+              <a:t>no rationale (a number, not a reason) · closed answer sets, text input only · “zero hallucinations” means always a valid type, not always the right answer · triage-grade accuracy (vendor benchmark ~68% vs ~73% for frontier LLMs) · early access, price may change. If the answer must be written, it belongs to an LLM.</a:t>
             </a:r>
           </a:p>
         </p:txBody>
@@ -9480,7 +9567,7 @@
                 </a:solidFill>
                 <a:latin typeface="Segoe UI"/>
               </a:rPr>
-              <a:t>Apply for the preview at typesafe.ai, then create an API key (comes with free credit).</a:t>
+              <a:t>Request early access at typesafe.ai, sign in at console.typesafe.ai, create an API key (free credit).</a:t>
             </a:r>
           </a:p>
           <a:p>

</xml_diff>

<commit_message>
Slide 2: drop the LangChain thumbnail, full-width flow + 'where it fits' bullet
Co-authored-by: Copilot App <223556219+Copilot@users.noreply.github.com>
</commit_message>
<xml_diff>
--- a/presentation/Jev_Team_Overview.pptx
+++ b/presentation/Jev_Team_Overview.pptx
@@ -5821,7 +5821,7 @@
         <p:spPr>
           <a:xfrm>
             <a:off x="457200" y="3931920"/>
-            <a:ext cx="1755648" cy="822960"/>
+            <a:ext cx="2816352" cy="822960"/>
           </a:xfrm>
           <a:prstGeom prst="homePlate">
             <a:avLst/>
@@ -5899,8 +5899,8 @@
         </p:nvSpPr>
         <p:spPr>
           <a:xfrm>
-            <a:off x="2212848" y="3931920"/>
-            <a:ext cx="1755648" cy="822960"/>
+            <a:off x="3273552" y="3931920"/>
+            <a:ext cx="2816352" cy="822960"/>
           </a:xfrm>
           <a:prstGeom prst="chevron">
             <a:avLst/>
@@ -5978,8 +5978,8 @@
         </p:nvSpPr>
         <p:spPr>
           <a:xfrm>
-            <a:off x="3968496" y="3931920"/>
-            <a:ext cx="1755648" cy="822960"/>
+            <a:off x="6089904" y="3931920"/>
+            <a:ext cx="2816352" cy="822960"/>
           </a:xfrm>
           <a:prstGeom prst="chevron">
             <a:avLst/>
@@ -6057,8 +6057,8 @@
         </p:nvSpPr>
         <p:spPr>
           <a:xfrm>
-            <a:off x="5724144" y="3931920"/>
-            <a:ext cx="1755648" cy="822960"/>
+            <a:off x="8906256" y="3931920"/>
+            <a:ext cx="2816352" cy="822960"/>
           </a:xfrm>
           <a:prstGeom prst="chevron">
             <a:avLst/>
@@ -6136,8 +6136,8 @@
         </p:nvSpPr>
         <p:spPr>
           <a:xfrm>
-            <a:off x="457200" y="5029200"/>
-            <a:ext cx="6583680" cy="1280160"/>
+            <a:off x="457200" y="5074920"/>
+            <a:ext cx="11247120" cy="1280160"/>
           </a:xfrm>
           <a:prstGeom prst="rect">
             <a:avLst/>
@@ -6155,11 +6155,11 @@
                 <a:spcPct val="105000"/>
               </a:lnSpc>
               <a:spcAft>
-                <a:spcPts val="800"/>
+                <a:spcPts val="1000"/>
               </a:spcAft>
             </a:pPr>
             <a:r>
-              <a:rPr sz="1500" b="0" i="0">
+              <a:rPr sz="1600" b="0" i="0">
                 <a:solidFill>
                   <a:srgbClr val="22D3EE"/>
                 </a:solidFill>
@@ -6168,7 +6168,7 @@
               <a:t>▸  </a:t>
             </a:r>
             <a:r>
-              <a:rPr sz="1500" b="0" i="0">
+              <a:rPr sz="1600" b="0" i="0">
                 <a:solidFill>
                   <a:srgbClr val="F5F6FA"/>
                 </a:solidFill>
@@ -6177,13 +6177,13 @@
               <a:t>All questions answered together </a:t>
             </a:r>
             <a:r>
-              <a:rPr sz="1500" b="0" i="0">
+              <a:rPr sz="1600" b="0" i="0">
                 <a:solidFill>
                   <a:srgbClr val="A3A9BC"/>
                 </a:solidFill>
                 <a:latin typeface="Segoe UI"/>
               </a:rPr>
-              <a:t>in ~0.1 s</a:t>
+              <a:t>in ~0.1 s · text only · calibrated over many decisions, not each one</a:t>
             </a:r>
           </a:p>
           <a:p>
@@ -6192,11 +6192,11 @@
                 <a:spcPct val="105000"/>
               </a:lnSpc>
               <a:spcAft>
-                <a:spcPts val="800"/>
+                <a:spcPts val="1000"/>
               </a:spcAft>
             </a:pPr>
             <a:r>
-              <a:rPr sz="1500" b="0" i="0">
+              <a:rPr sz="1600" b="0" i="0">
                 <a:solidFill>
                   <a:srgbClr val="22D3EE"/>
                 </a:solidFill>
@@ -6205,69 +6205,38 @@
               <a:t>▸  </a:t>
             </a:r>
             <a:r>
-              <a:rPr sz="1500" b="0" i="0">
+              <a:rPr sz="1600" b="0" i="0">
                 <a:solidFill>
                   <a:srgbClr val="F5F6FA"/>
                 </a:solidFill>
                 <a:latin typeface="Segoe UI Semibold"/>
               </a:rPr>
-              <a:t>Text only; </a:t>
-            </a:r>
-            <a:r>
-              <a:rPr sz="1500" b="0" i="0">
+              <a:t>Where it fits: </a:t>
+            </a:r>
+            <a:r>
+              <a:rPr sz="1600" b="0" i="0">
                 <a:solidFill>
                   <a:srgbClr val="A3A9BC"/>
                 </a:solidFill>
                 <a:latin typeface="Segoe UI"/>
               </a:rPr>
-              <a:t>calibrated over many decisions, not each one</a:t>
-            </a:r>
-          </a:p>
-        </p:txBody>
-      </p:sp>
-      <p:pic>
-        <p:nvPicPr>
-          <p:cNvPr id="25" name="Picture 24" descr="yt_VE5dsWll06M.jpg">
-            <a:hlinkClick r:id="rId3"/>
-          </p:cNvPr>
-          <p:cNvPicPr>
-            <a:picLocks noChangeAspect="1"/>
-          </p:cNvPicPr>
-          <p:nvPr/>
-        </p:nvPicPr>
-        <p:blipFill>
-          <a:blip r:embed="rId2"/>
-          <a:stretch>
-            <a:fillRect/>
-          </a:stretch>
-        </p:blipFill>
-        <p:spPr>
-          <a:xfrm>
-            <a:off x="7589520" y="3611880"/>
-            <a:ext cx="4160520" cy="2340292"/>
-          </a:xfrm>
-          <a:prstGeom prst="rect">
-            <a:avLst/>
-          </a:prstGeom>
-          <a:ln w="12700">
-            <a:solidFill>
-              <a:srgbClr val="33384A"/>
-            </a:solidFill>
-          </a:ln>
-        </p:spPr>
-      </p:pic>
-      <p:sp>
-        <p:nvSpPr>
-          <p:cNvPr id="26" name="TextBox 25">
-            <a:hlinkClick r:id="rId3"/>
+              <a:t>model routing · tool-call guardrails · LLM-as-judge around your agent</a:t>
+            </a:r>
+          </a:p>
+        </p:txBody>
+      </p:sp>
+      <p:sp>
+        <p:nvSpPr>
+          <p:cNvPr id="25" name="TextBox 24">
+            <a:hlinkClick r:id="rId2"/>
           </p:cNvPr>
           <p:cNvSpPr txBox="1"/>
           <p:nvPr/>
         </p:nvSpPr>
         <p:spPr>
           <a:xfrm>
-            <a:off x="7589520" y="5998464"/>
-            <a:ext cx="4160520" cy="274320"/>
+            <a:off x="457200" y="6172200"/>
+            <a:ext cx="11247120" cy="274320"/>
           </a:xfrm>
           <a:prstGeom prst="rect">
             <a:avLst/>
@@ -6295,7 +6264,7 @@
                 </a:solidFill>
                 <a:latin typeface="Segoe UI"/>
               </a:rPr>
-              <a:t>▶  LangChain: Jev in the agent harness - routing · auto mode · judge</a:t>
+              <a:t>▶  LangChain: “Building a Harness with Jev”</a:t>
             </a:r>
           </a:p>
         </p:txBody>

</xml_diff>

<commit_message>
Slide 2: make 'where it fits' general, harness topics only in the video link
Co-authored-by: Copilot App <223556219+Copilot@users.noreply.github.com>
</commit_message>
<xml_diff>
--- a/presentation/Jev_Team_Overview.pptx
+++ b/presentation/Jev_Team_Overview.pptx
@@ -6220,7 +6220,7 @@
                 </a:solidFill>
                 <a:latin typeface="Segoe UI"/>
               </a:rPr>
-              <a:t>model routing · tool-call guardrails · LLM-as-judge around your agent</a:t>
+              <a:t>any repetitive judgement in your product - classify, prioritise, check; LLMs keep the writing</a:t>
             </a:r>
           </a:p>
         </p:txBody>
@@ -6264,7 +6264,7 @@
                 </a:solidFill>
                 <a:latin typeface="Segoe UI"/>
               </a:rPr>
-              <a:t>▶  LangChain: “Building a Harness with Jev”</a:t>
+              <a:t>▶  More: LangChain “Building a Harness with Jev” (routing, guardrails, judge)</a:t>
             </a:r>
           </a:p>
         </p:txBody>

</xml_diff>

<commit_message>
Slide 2: harness topics as a sub-bullet under 'Where it fits'
Co-authored-by: Copilot App <223556219+Copilot@users.noreply.github.com>
</commit_message>
<xml_diff>
--- a/presentation/Jev_Team_Overview.pptx
+++ b/presentation/Jev_Team_Overview.pptx
@@ -6136,8 +6136,8 @@
         </p:nvSpPr>
         <p:spPr>
           <a:xfrm>
-            <a:off x="457200" y="5074920"/>
-            <a:ext cx="11247120" cy="1280160"/>
+            <a:off x="457200" y="4937760"/>
+            <a:ext cx="11247120" cy="914400"/>
           </a:xfrm>
           <a:prstGeom prst="rect">
             <a:avLst/>
@@ -6227,16 +6227,14 @@
       </p:sp>
       <p:sp>
         <p:nvSpPr>
-          <p:cNvPr id="25" name="TextBox 24">
-            <a:hlinkClick r:id="rId2"/>
-          </p:cNvPr>
+          <p:cNvPr id="25" name="TextBox 24"/>
           <p:cNvSpPr txBox="1"/>
           <p:nvPr/>
         </p:nvSpPr>
         <p:spPr>
           <a:xfrm>
-            <a:off x="457200" y="6172200"/>
-            <a:ext cx="11247120" cy="274320"/>
+            <a:off x="868680" y="5687568"/>
+            <a:ext cx="10881360" cy="365760"/>
           </a:xfrm>
           <a:prstGeom prst="rect">
             <a:avLst/>
@@ -6258,13 +6256,66 @@
               </a:spcAft>
             </a:pPr>
             <a:r>
+              <a:rPr sz="1400" b="0" i="0">
+                <a:solidFill>
+                  <a:srgbClr val="F5F6FA"/>
+                </a:solidFill>
+                <a:latin typeface="Segoe UI Semibold"/>
+              </a:rPr>
+              <a:t>–  In AI agents (harness engineering): </a:t>
+            </a:r>
+            <a:r>
+              <a:rPr sz="1400" b="0" i="0">
+                <a:solidFill>
+                  <a:srgbClr val="A3A9BC"/>
+                </a:solidFill>
+                <a:latin typeface="Segoe UI"/>
+              </a:rPr>
+              <a:t>model routing · tool-call guardrails · LLM-as-judge</a:t>
+            </a:r>
+          </a:p>
+        </p:txBody>
+      </p:sp>
+      <p:sp>
+        <p:nvSpPr>
+          <p:cNvPr id="26" name="TextBox 25">
+            <a:hlinkClick r:id="rId2"/>
+          </p:cNvPr>
+          <p:cNvSpPr txBox="1"/>
+          <p:nvPr/>
+        </p:nvSpPr>
+        <p:spPr>
+          <a:xfrm>
+            <a:off x="868680" y="6089904"/>
+            <a:ext cx="10881360" cy="274320"/>
+          </a:xfrm>
+          <a:prstGeom prst="rect">
+            <a:avLst/>
+          </a:prstGeom>
+          <a:noFill/>
+        </p:spPr>
+        <p:txBody>
+          <a:bodyPr wrap="square" anchor="t" lIns="36576" rIns="36576" tIns="36576" bIns="36576">
+            <a:spAutoFit/>
+          </a:bodyPr>
+          <a:lstStyle/>
+          <a:p>
+            <a:pPr algn="l">
+              <a:lnSpc>
+                <a:spcPct val="100000"/>
+              </a:lnSpc>
+              <a:spcAft>
+                <a:spcPts val="0"/>
+              </a:spcAft>
+            </a:pPr>
+            <a:r>
               <a:rPr sz="1000" b="0" i="0" u="sng">
                 <a:solidFill>
                   <a:srgbClr val="A3A9BC"/>
                 </a:solidFill>
                 <a:latin typeface="Segoe UI"/>
               </a:rPr>
-              <a:t>▶  More: LangChain “Building a Harness with Jev” (routing, guardrails, judge)</a:t>
+              <a:t>▶  LangChain: “Building a Harness with Jev”</a:t>
             </a:r>
           </a:p>
         </p:txBody>

</xml_diff>